<commit_message>
feat(slides): auto-embed a PineBuds photo from slides/assets
scripts/make_lt_pptx.py now looks for slides/assets/pinebuds.<ext> and, when
present, fits it into the slide-5 frame preserving aspect ratio, with a
caption underneath. Without the file it draws a placeholder that names the
path to drop it at, so the deck still builds.

Enlarges the frame to 4.58 x 2.10 in and reflows the two panels below it.

Co-Authored-By: Claude Opus 5 (1M context) <noreply@anthropic.com>
Claude-Session: https://claude.ai/code/session_01GfWBNUHfEor9QCWXsKfWWj
</commit_message>
<xml_diff>
--- a/slides/lt-ear-parallel.pptx
+++ b/slides/lt-ear-parallel.pptx
@@ -18657,7 +18657,7 @@
         <p:spPr>
           <a:xfrm>
             <a:off x="7498079" y="1133856"/>
-            <a:ext cx="4187952" cy="1417320"/>
+            <a:ext cx="4187952" cy="1920240"/>
           </a:xfrm>
           <a:prstGeom prst="rect">
             <a:avLst/>
@@ -18701,7 +18701,7 @@
         <p:spPr>
           <a:xfrm>
             <a:off x="7498079" y="1133856"/>
-            <a:ext cx="4187952" cy="1417320"/>
+            <a:ext cx="4187952" cy="1920240"/>
           </a:xfrm>
           <a:prstGeom prst="rect">
             <a:avLst/>
@@ -18716,11 +18716,11 @@
           <a:p>
             <a:pPr algn="ctr">
               <a:spcAft>
-                <a:spcPts val="400"/>
-              </a:spcAft>
-            </a:pPr>
-            <a:r>
-              <a:rPr sz="1300" b="0" i="0">
+                <a:spcPts val="300"/>
+              </a:spcAft>
+            </a:pPr>
+            <a:r>
+              <a:rPr sz="1200" b="0" i="0">
                 <a:solidFill>
                   <a:srgbClr val="8C8C8C"/>
                 </a:solidFill>
@@ -18728,7 +18728,9 @@
                 <a:ea typeface="Meiryo"/>
                 <a:cs typeface="Meiryo"/>
               </a:rPr>
-              <a:t>[  PineBuds Pro の写真をここに  ]</a:t>
+              <a:t>[  PineBuds Pro の写真をここに  ]
+slides/assets/pinebuds.jpg を置いて
+scripts/make_lt_pptx.py を再実行</a:t>
             </a:r>
           </a:p>
         </p:txBody>
@@ -18741,8 +18743,8 @@
         </p:nvSpPr>
         <p:spPr>
           <a:xfrm>
-            <a:off x="7498079" y="2697480"/>
-            <a:ext cx="4187952" cy="1920240"/>
+            <a:off x="7498079" y="3200400"/>
+            <a:ext cx="4187952" cy="1737360"/>
           </a:xfrm>
           <a:prstGeom prst="rect">
             <a:avLst/>
@@ -18785,7 +18787,7 @@
         </p:nvSpPr>
         <p:spPr>
           <a:xfrm>
-            <a:off x="7498079" y="2697480"/>
+            <a:off x="7498079" y="3200400"/>
             <a:ext cx="4187952" cy="384048"/>
           </a:xfrm>
           <a:prstGeom prst="rect">
@@ -18829,7 +18831,7 @@
         </p:nvSpPr>
         <p:spPr>
           <a:xfrm>
-            <a:off x="7498079" y="2697480"/>
+            <a:off x="7498079" y="3200400"/>
             <a:ext cx="4187952" cy="384048"/>
           </a:xfrm>
           <a:prstGeom prst="rect">
@@ -18870,8 +18872,8 @@
         </p:nvSpPr>
         <p:spPr>
           <a:xfrm>
-            <a:off x="7498079" y="3081528"/>
-            <a:ext cx="4187952" cy="1536192"/>
+            <a:off x="7498079" y="3584448"/>
+            <a:ext cx="4187952" cy="1353312"/>
           </a:xfrm>
           <a:prstGeom prst="rect">
             <a:avLst/>
@@ -18965,8 +18967,8 @@
         </p:nvSpPr>
         <p:spPr>
           <a:xfrm>
-            <a:off x="7498079" y="4773168"/>
-            <a:ext cx="4187952" cy="1298448"/>
+            <a:off x="7498079" y="5084064"/>
+            <a:ext cx="4187952" cy="1170432"/>
           </a:xfrm>
           <a:prstGeom prst="rect">
             <a:avLst/>
@@ -19009,8 +19011,8 @@
         </p:nvSpPr>
         <p:spPr>
           <a:xfrm>
-            <a:off x="7498079" y="4773168"/>
-            <a:ext cx="4187952" cy="1298448"/>
+            <a:off x="7498079" y="5084064"/>
+            <a:ext cx="4187952" cy="1170432"/>
           </a:xfrm>
           <a:prstGeom prst="rect">
             <a:avLst/>

</xml_diff>

<commit_message>
tidy(slides): drop the golden-reference panel from the overview slide
Removes the "自作アダプタが嘘をついていない証明" panel and its fork diagram.
The layer stack now spans the full width and the SDK constraints sit under
it as a band, which reads as one picture instead of two competing columns.

Co-Authored-By: Claude Opus 5 (1M context) <noreply@anthropic.com>
Claude-Session: https://claude.ai/code/session_01GfWBNUHfEor9QCWXsKfWWj
</commit_message>
<xml_diff>
--- a/slides/lt-ear-parallel.pptx
+++ b/slides/lt-ear-parallel.pptx
@@ -20455,7 +20455,7 @@
         <p:spPr>
           <a:xfrm>
             <a:off x="502920" y="1115568"/>
-            <a:ext cx="6903720" cy="694944"/>
+            <a:ext cx="11185855" cy="713232"/>
           </a:xfrm>
           <a:prstGeom prst="rect">
             <a:avLst/>
@@ -20498,8 +20498,8 @@
         </p:nvSpPr>
         <p:spPr>
           <a:xfrm>
-            <a:off x="594360" y="1161288"/>
-            <a:ext cx="6720840" cy="292608"/>
+            <a:off x="612648" y="1170432"/>
+            <a:ext cx="10966399" cy="310896"/>
           </a:xfrm>
           <a:prstGeom prst="rect">
             <a:avLst/>
@@ -20518,7 +20518,7 @@
               </a:spcAft>
             </a:pPr>
             <a:r>
-              <a:rPr sz="1300" b="1" i="0">
+              <a:rPr sz="1400" b="1" i="0">
                 <a:solidFill>
                   <a:srgbClr val="111111"/>
                 </a:solidFill>
@@ -20539,8 +20539,8 @@
         </p:nvSpPr>
         <p:spPr>
           <a:xfrm>
-            <a:off x="594360" y="1444752"/>
-            <a:ext cx="6720840" cy="329184"/>
+            <a:off x="612648" y="1463040"/>
+            <a:ext cx="10966399" cy="329184"/>
           </a:xfrm>
           <a:prstGeom prst="rect">
             <a:avLst/>
@@ -20559,7 +20559,7 @@
               </a:spcAft>
             </a:pPr>
             <a:r>
-              <a:rPr sz="1050" b="0" i="0">
+              <a:rPr sz="1150" b="0" i="0">
                 <a:solidFill>
                   <a:srgbClr val="5A5A5A"/>
                 </a:solidFill>
@@ -20580,8 +20580,8 @@
         </p:nvSpPr>
         <p:spPr>
           <a:xfrm>
-            <a:off x="502920" y="1883664"/>
-            <a:ext cx="6903720" cy="694944"/>
+            <a:off x="502920" y="1901952"/>
+            <a:ext cx="11185855" cy="713232"/>
           </a:xfrm>
           <a:prstGeom prst="rect">
             <a:avLst/>
@@ -20624,8 +20624,8 @@
         </p:nvSpPr>
         <p:spPr>
           <a:xfrm>
-            <a:off x="594360" y="1929384"/>
-            <a:ext cx="6720840" cy="292608"/>
+            <a:off x="612648" y="1956816"/>
+            <a:ext cx="10966399" cy="310896"/>
           </a:xfrm>
           <a:prstGeom prst="rect">
             <a:avLst/>
@@ -20644,7 +20644,7 @@
               </a:spcAft>
             </a:pPr>
             <a:r>
-              <a:rPr sz="1300" b="1" i="0">
+              <a:rPr sz="1400" b="1" i="0">
                 <a:solidFill>
                   <a:srgbClr val="111111"/>
                 </a:solidFill>
@@ -20665,8 +20665,8 @@
         </p:nvSpPr>
         <p:spPr>
           <a:xfrm>
-            <a:off x="594360" y="2212848"/>
-            <a:ext cx="6720840" cy="329184"/>
+            <a:off x="612648" y="2249424"/>
+            <a:ext cx="10966399" cy="329184"/>
           </a:xfrm>
           <a:prstGeom prst="rect">
             <a:avLst/>
@@ -20685,7 +20685,7 @@
               </a:spcAft>
             </a:pPr>
             <a:r>
-              <a:rPr sz="1050" b="0" i="0">
+              <a:rPr sz="1150" b="0" i="0">
                 <a:solidFill>
                   <a:srgbClr val="5A5A5A"/>
                 </a:solidFill>
@@ -20706,8 +20706,8 @@
         </p:nvSpPr>
         <p:spPr>
           <a:xfrm>
-            <a:off x="502920" y="2651760"/>
-            <a:ext cx="6903720" cy="694944"/>
+            <a:off x="502920" y="2688336"/>
+            <a:ext cx="11185855" cy="713232"/>
           </a:xfrm>
           <a:prstGeom prst="rect">
             <a:avLst/>
@@ -20750,8 +20750,8 @@
         </p:nvSpPr>
         <p:spPr>
           <a:xfrm>
-            <a:off x="594360" y="2697479"/>
-            <a:ext cx="6720840" cy="292608"/>
+            <a:off x="612648" y="2743200"/>
+            <a:ext cx="10966399" cy="310896"/>
           </a:xfrm>
           <a:prstGeom prst="rect">
             <a:avLst/>
@@ -20770,7 +20770,7 @@
               </a:spcAft>
             </a:pPr>
             <a:r>
-              <a:rPr sz="1300" b="1" i="0">
+              <a:rPr sz="1400" b="1" i="0">
                 <a:solidFill>
                   <a:srgbClr val="111111"/>
                 </a:solidFill>
@@ -20791,8 +20791,8 @@
         </p:nvSpPr>
         <p:spPr>
           <a:xfrm>
-            <a:off x="594360" y="2980944"/>
-            <a:ext cx="6720840" cy="329184"/>
+            <a:off x="612648" y="3035808"/>
+            <a:ext cx="10966399" cy="329184"/>
           </a:xfrm>
           <a:prstGeom prst="rect">
             <a:avLst/>
@@ -20811,7 +20811,7 @@
               </a:spcAft>
             </a:pPr>
             <a:r>
-              <a:rPr sz="1050" b="0" i="0">
+              <a:rPr sz="1150" b="0" i="0">
                 <a:solidFill>
                   <a:srgbClr val="5A5A5A"/>
                 </a:solidFill>
@@ -20832,8 +20832,8 @@
         </p:nvSpPr>
         <p:spPr>
           <a:xfrm>
-            <a:off x="502920" y="3419856"/>
-            <a:ext cx="6903720" cy="694944"/>
+            <a:off x="502920" y="3474720"/>
+            <a:ext cx="11185855" cy="713232"/>
           </a:xfrm>
           <a:prstGeom prst="rect">
             <a:avLst/>
@@ -20876,8 +20876,8 @@
         </p:nvSpPr>
         <p:spPr>
           <a:xfrm>
-            <a:off x="594360" y="3465576"/>
-            <a:ext cx="6720840" cy="292608"/>
+            <a:off x="612648" y="3529584"/>
+            <a:ext cx="10966399" cy="310896"/>
           </a:xfrm>
           <a:prstGeom prst="rect">
             <a:avLst/>
@@ -20896,7 +20896,7 @@
               </a:spcAft>
             </a:pPr>
             <a:r>
-              <a:rPr sz="1300" b="1" i="0">
+              <a:rPr sz="1400" b="1" i="0">
                 <a:solidFill>
                   <a:srgbClr val="111111"/>
                 </a:solidFill>
@@ -20917,8 +20917,8 @@
         </p:nvSpPr>
         <p:spPr>
           <a:xfrm>
-            <a:off x="594360" y="3749040"/>
-            <a:ext cx="6720840" cy="329184"/>
+            <a:off x="612648" y="3822191"/>
+            <a:ext cx="10966399" cy="329184"/>
           </a:xfrm>
           <a:prstGeom prst="rect">
             <a:avLst/>
@@ -20937,7 +20937,7 @@
               </a:spcAft>
             </a:pPr>
             <a:r>
-              <a:rPr sz="1050" b="0" i="0">
+              <a:rPr sz="1150" b="0" i="0">
                 <a:solidFill>
                   <a:srgbClr val="5A5A5A"/>
                 </a:solidFill>
@@ -20958,8 +20958,8 @@
         </p:nvSpPr>
         <p:spPr>
           <a:xfrm>
-            <a:off x="502920" y="4187952"/>
-            <a:ext cx="6903720" cy="694944"/>
+            <a:off x="502920" y="4261104"/>
+            <a:ext cx="11185855" cy="713232"/>
           </a:xfrm>
           <a:prstGeom prst="rect">
             <a:avLst/>
@@ -21002,8 +21002,8 @@
         </p:nvSpPr>
         <p:spPr>
           <a:xfrm>
-            <a:off x="594360" y="4233672"/>
-            <a:ext cx="6720840" cy="292608"/>
+            <a:off x="612648" y="4315968"/>
+            <a:ext cx="10966399" cy="310896"/>
           </a:xfrm>
           <a:prstGeom prst="rect">
             <a:avLst/>
@@ -21022,7 +21022,7 @@
               </a:spcAft>
             </a:pPr>
             <a:r>
-              <a:rPr sz="1300" b="1" i="0">
+              <a:rPr sz="1400" b="1" i="0">
                 <a:solidFill>
                   <a:srgbClr val="111111"/>
                 </a:solidFill>
@@ -21043,8 +21043,8 @@
         </p:nvSpPr>
         <p:spPr>
           <a:xfrm>
-            <a:off x="594360" y="4517136"/>
-            <a:ext cx="6720840" cy="329184"/>
+            <a:off x="612648" y="4608576"/>
+            <a:ext cx="10966399" cy="329184"/>
           </a:xfrm>
           <a:prstGeom prst="rect">
             <a:avLst/>
@@ -21063,7 +21063,7 @@
               </a:spcAft>
             </a:pPr>
             <a:r>
-              <a:rPr sz="1050" b="0" i="0">
+              <a:rPr sz="1150" b="0" i="0">
                 <a:solidFill>
                   <a:srgbClr val="5A5A5A"/>
                 </a:solidFill>
@@ -21078,55 +21078,14 @@
       </p:sp>
       <p:sp>
         <p:nvSpPr>
-          <p:cNvPr id="20" name="TextBox 19"/>
-          <p:cNvSpPr txBox="1"/>
-          <p:nvPr/>
-        </p:nvSpPr>
-        <p:spPr>
-          <a:xfrm>
-            <a:off x="502920" y="5010912"/>
-            <a:ext cx="6903720" cy="384048"/>
-          </a:xfrm>
-          <a:prstGeom prst="rect">
-            <a:avLst/>
-          </a:prstGeom>
-          <a:noFill/>
-        </p:spPr>
-        <p:txBody>
-          <a:bodyPr wrap="square" lIns="18288" rIns="18288" tIns="10972" bIns="10972" anchor="t">
-            <a:spAutoFit/>
-          </a:bodyPr>
-          <a:lstStyle/>
-          <a:p>
-            <a:pPr algn="l">
-              <a:spcAft>
-                <a:spcPts val="400"/>
-              </a:spcAft>
-            </a:pPr>
-            <a:r>
-              <a:rPr sz="1150" b="0" i="0">
-                <a:solidFill>
-                  <a:srgbClr val="5A5A5A"/>
-                </a:solidFill>
-                <a:latin typeface="Meiryo"/>
-                <a:ea typeface="Meiryo"/>
-                <a:cs typeface="Meiryo"/>
-              </a:rPr>
-              <a:t>規模: adapters 926 行 / firmware 統合 1,656 行 / tests 1,846 行 / 設計ドキュメント 2,643 行</a:t>
-            </a:r>
-          </a:p>
-        </p:txBody>
-      </p:sp>
-      <p:sp>
-        <p:nvSpPr>
-          <p:cNvPr id="21" name="Rectangle 20"/>
+          <p:cNvPr id="20" name="Rectangle 19"/>
           <p:cNvSpPr/>
           <p:nvPr/>
         </p:nvSpPr>
         <p:spPr>
           <a:xfrm>
-            <a:off x="7607808" y="1115568"/>
-            <a:ext cx="4078224" cy="2505456"/>
+            <a:off x="502920" y="5102352"/>
+            <a:ext cx="11185855" cy="1005840"/>
           </a:xfrm>
           <a:prstGeom prst="rect">
             <a:avLst/>
@@ -21163,14 +21122,14 @@
       </p:sp>
       <p:sp>
         <p:nvSpPr>
-          <p:cNvPr id="22" name="Rectangle 21"/>
+          <p:cNvPr id="21" name="Rectangle 20"/>
           <p:cNvSpPr/>
           <p:nvPr/>
         </p:nvSpPr>
         <p:spPr>
           <a:xfrm>
-            <a:off x="7607808" y="1115568"/>
-            <a:ext cx="4078224" cy="384048"/>
+            <a:off x="502920" y="5102352"/>
+            <a:ext cx="11185855" cy="384048"/>
           </a:xfrm>
           <a:prstGeom prst="rect">
             <a:avLst/>
@@ -21207,14 +21166,14 @@
       </p:sp>
       <p:sp>
         <p:nvSpPr>
-          <p:cNvPr id="23" name="TextBox 22"/>
+          <p:cNvPr id="22" name="TextBox 21"/>
           <p:cNvSpPr txBox="1"/>
           <p:nvPr/>
         </p:nvSpPr>
         <p:spPr>
           <a:xfrm>
-            <a:off x="7607808" y="1115568"/>
-            <a:ext cx="4078224" cy="384048"/>
+            <a:off x="502920" y="5102352"/>
+            <a:ext cx="11185855" cy="384048"/>
           </a:xfrm>
           <a:prstGeom prst="rect">
             <a:avLst/>
@@ -21233,7 +21192,7 @@
               </a:spcAft>
             </a:pPr>
             <a:r>
-              <a:rPr sz="1350" b="1" i="0">
+              <a:rPr sz="1400" b="1" i="0">
                 <a:solidFill>
                   <a:srgbClr val="111111"/>
                 </a:solidFill>
@@ -21241,65 +21200,21 @@
                 <a:ea typeface="Meiryo"/>
                 <a:cs typeface="Meiryo"/>
               </a:rPr>
-              <a:t>自作アダプタが嘘をついていない証明</a:t>
-            </a:r>
-          </a:p>
-        </p:txBody>
-      </p:sp>
-      <p:sp>
-        <p:nvSpPr>
-          <p:cNvPr id="24" name="Rectangle 23"/>
-          <p:cNvSpPr/>
-          <p:nvPr/>
-        </p:nvSpPr>
-        <p:spPr>
-          <a:xfrm>
-            <a:off x="7790688" y="1591056"/>
-            <a:ext cx="3712463" cy="365760"/>
-          </a:xfrm>
-          <a:prstGeom prst="rect">
-            <a:avLst/>
-          </a:prstGeom>
-          <a:solidFill>
-            <a:srgbClr val="FFFFFF"/>
-          </a:solidFill>
-          <a:ln w="9525">
-            <a:solidFill>
-              <a:srgbClr val="9E9E9E"/>
-            </a:solidFill>
-          </a:ln>
-          <a:effectLst/>
-        </p:spPr>
-        <p:style>
-          <a:lnRef idx="1">
-            <a:schemeClr val="accent1"/>
-          </a:lnRef>
-          <a:fillRef idx="3">
-            <a:schemeClr val="accent1"/>
-          </a:fillRef>
-          <a:effectRef idx="2">
-            <a:schemeClr val="accent1"/>
-          </a:effectRef>
-          <a:fontRef idx="minor">
-            <a:schemeClr val="lt1"/>
-          </a:fontRef>
-        </p:style>
-        <p:txBody>
-          <a:bodyPr rtlCol="0" anchor="ctr"/>
-          <a:lstStyle/>
-          <a:p/>
-        </p:txBody>
-      </p:sp>
-      <p:sp>
-        <p:nvSpPr>
-          <p:cNvPr id="25" name="TextBox 24"/>
+              <a:t>SDK に合わせるしかない制約</a:t>
+            </a:r>
+          </a:p>
+        </p:txBody>
+      </p:sp>
+      <p:sp>
+        <p:nvSpPr>
+          <p:cNvPr id="23" name="TextBox 22"/>
           <p:cNvSpPr txBox="1"/>
           <p:nvPr/>
         </p:nvSpPr>
         <p:spPr>
           <a:xfrm>
-            <a:off x="7790688" y="1591056"/>
-            <a:ext cx="3712463" cy="365760"/>
+            <a:off x="502920" y="5486400"/>
+            <a:ext cx="11185855" cy="621792"/>
           </a:xfrm>
           <a:prstGeom prst="rect">
             <a:avLst/>
@@ -21307,18 +21222,18 @@
           <a:noFill/>
         </p:spPr>
         <p:txBody>
-          <a:bodyPr wrap="square" lIns="27432" rIns="27432" tIns="16459" bIns="16459" anchor="ctr">
+          <a:bodyPr wrap="square" lIns="109728" rIns="109728" tIns="65836" bIns="65836" anchor="t">
             <a:spAutoFit/>
           </a:bodyPr>
           <a:lstStyle/>
           <a:p>
-            <a:pPr algn="ctr">
+            <a:pPr algn="l">
               <a:spcAft>
                 <a:spcPts val="400"/>
               </a:spcAft>
             </a:pPr>
             <a:r>
-              <a:rPr sz="1100" b="1" i="0">
+              <a:rPr sz="1200" b="0" i="0">
                 <a:solidFill>
                   <a:srgbClr val="111111"/>
                 </a:solidFill>
@@ -21326,367 +21241,39 @@
                 <a:ea typeface="Meiryo"/>
                 <a:cs typeface="Meiryo"/>
               </a:rPr>
-              <a:t>bench/gemm_mpi_omp.cpp  (1 ソース・無改変)</a:t>
-            </a:r>
-          </a:p>
-        </p:txBody>
-      </p:sp>
-      <p:sp>
-        <p:nvSpPr>
-          <p:cNvPr id="26" name="Rectangle 25"/>
-          <p:cNvSpPr/>
-          <p:nvPr/>
-        </p:nvSpPr>
-        <p:spPr>
-          <a:xfrm>
-            <a:off x="7790688" y="2084831"/>
-            <a:ext cx="1176527" cy="658368"/>
-          </a:xfrm>
-          <a:prstGeom prst="rect">
-            <a:avLst/>
-          </a:prstGeom>
-          <a:solidFill>
-            <a:srgbClr val="FFFFFF"/>
-          </a:solidFill>
-          <a:ln w="9525">
-            <a:solidFill>
-              <a:srgbClr val="9E9E9E"/>
-            </a:solidFill>
-          </a:ln>
-          <a:effectLst/>
-        </p:spPr>
-        <p:style>
-          <a:lnRef idx="1">
-            <a:schemeClr val="accent1"/>
-          </a:lnRef>
-          <a:fillRef idx="3">
-            <a:schemeClr val="accent1"/>
-          </a:fillRef>
-          <a:effectRef idx="2">
-            <a:schemeClr val="accent1"/>
-          </a:effectRef>
-          <a:fontRef idx="minor">
-            <a:schemeClr val="lt1"/>
-          </a:fontRef>
-        </p:style>
-        <p:txBody>
-          <a:bodyPr rtlCol="0" anchor="ctr"/>
-          <a:lstStyle/>
-          <a:p/>
-        </p:txBody>
-      </p:sp>
-      <p:sp>
-        <p:nvSpPr>
-          <p:cNvPr id="27" name="TextBox 26"/>
+              <a:t>・ -std=gnu++98 / -fno-exceptions / -fno-rtti → C++11 以降が使えない     ・ ヒープ禁止・STL 禁止・静的バッファのみ</a:t>
+            </a:r>
+          </a:p>
+          <a:p>
+            <a:pPr algn="l">
+              <a:spcAft>
+                <a:spcPts val="0"/>
+              </a:spcAft>
+            </a:pPr>
+            <a:r>
+              <a:rPr sz="1200" b="0" i="0">
+                <a:solidFill>
+                  <a:srgbClr val="111111"/>
+                </a:solidFill>
+                <a:latin typeface="Meiryo"/>
+                <a:ea typeface="Meiryo"/>
+                <a:cs typeface="Meiryo"/>
+              </a:rPr>
+              <a:t>・ double 禁止 (単精度 FPU のみ、リテラルは 1.0f)     ・ make check98 で機械的に担保</a:t>
+            </a:r>
+          </a:p>
+        </p:txBody>
+      </p:sp>
+      <p:sp>
+        <p:nvSpPr>
+          <p:cNvPr id="24" name="TextBox 23"/>
           <p:cNvSpPr txBox="1"/>
           <p:nvPr/>
         </p:nvSpPr>
         <p:spPr>
           <a:xfrm>
-            <a:off x="7790688" y="2084831"/>
-            <a:ext cx="1176527" cy="658368"/>
-          </a:xfrm>
-          <a:prstGeom prst="rect">
-            <a:avLst/>
-          </a:prstGeom>
-          <a:noFill/>
-        </p:spPr>
-        <p:txBody>
-          <a:bodyPr wrap="square" lIns="18288" rIns="18288" tIns="10972" bIns="10972" anchor="ctr">
-            <a:spAutoFit/>
-          </a:bodyPr>
-          <a:lstStyle/>
-          <a:p>
-            <a:pPr algn="ctr">
-              <a:spcAft>
-                <a:spcPts val="0"/>
-              </a:spcAft>
-            </a:pPr>
-            <a:r>
-              <a:rPr sz="950" b="0" i="0">
-                <a:solidFill>
-                  <a:srgbClr val="111111"/>
-                </a:solidFill>
-                <a:latin typeface="Meiryo"/>
-                <a:ea typeface="Meiryo"/>
-                <a:cs typeface="Meiryo"/>
-              </a:rPr>
-              <a:t>本物の
-OpenMPI
-np=1</a:t>
-            </a:r>
-          </a:p>
-        </p:txBody>
-      </p:sp>
-      <p:sp>
-        <p:nvSpPr>
-          <p:cNvPr id="28" name="Rectangle 27"/>
-          <p:cNvSpPr/>
-          <p:nvPr/>
-        </p:nvSpPr>
-        <p:spPr>
-          <a:xfrm>
-            <a:off x="9058656" y="2084831"/>
-            <a:ext cx="1176527" cy="658368"/>
-          </a:xfrm>
-          <a:prstGeom prst="rect">
-            <a:avLst/>
-          </a:prstGeom>
-          <a:solidFill>
-            <a:srgbClr val="FFFFFF"/>
-          </a:solidFill>
-          <a:ln w="9525">
-            <a:solidFill>
-              <a:srgbClr val="9E9E9E"/>
-            </a:solidFill>
-          </a:ln>
-          <a:effectLst/>
-        </p:spPr>
-        <p:style>
-          <a:lnRef idx="1">
-            <a:schemeClr val="accent1"/>
-          </a:lnRef>
-          <a:fillRef idx="3">
-            <a:schemeClr val="accent1"/>
-          </a:fillRef>
-          <a:effectRef idx="2">
-            <a:schemeClr val="accent1"/>
-          </a:effectRef>
-          <a:fontRef idx="minor">
-            <a:schemeClr val="lt1"/>
-          </a:fontRef>
-        </p:style>
-        <p:txBody>
-          <a:bodyPr rtlCol="0" anchor="ctr"/>
-          <a:lstStyle/>
-          <a:p/>
-        </p:txBody>
-      </p:sp>
-      <p:sp>
-        <p:nvSpPr>
-          <p:cNvPr id="29" name="TextBox 28"/>
-          <p:cNvSpPr txBox="1"/>
-          <p:nvPr/>
-        </p:nvSpPr>
-        <p:spPr>
-          <a:xfrm>
-            <a:off x="9058656" y="2084831"/>
-            <a:ext cx="1176527" cy="658368"/>
-          </a:xfrm>
-          <a:prstGeom prst="rect">
-            <a:avLst/>
-          </a:prstGeom>
-          <a:noFill/>
-        </p:spPr>
-        <p:txBody>
-          <a:bodyPr wrap="square" lIns="18288" rIns="18288" tIns="10972" bIns="10972" anchor="ctr">
-            <a:spAutoFit/>
-          </a:bodyPr>
-          <a:lstStyle/>
-          <a:p>
-            <a:pPr algn="ctr">
-              <a:spcAft>
-                <a:spcPts val="0"/>
-              </a:spcAft>
-            </a:pPr>
-            <a:r>
-              <a:rPr sz="950" b="0" i="0">
-                <a:solidFill>
-                  <a:srgbClr val="111111"/>
-                </a:solidFill>
-                <a:latin typeface="Meiryo"/>
-                <a:ea typeface="Meiryo"/>
-                <a:cs typeface="Meiryo"/>
-              </a:rPr>
-              <a:t>本物の
-OpenMPI
-np=2</a:t>
-            </a:r>
-          </a:p>
-        </p:txBody>
-      </p:sp>
-      <p:sp>
-        <p:nvSpPr>
-          <p:cNvPr id="30" name="Rectangle 29"/>
-          <p:cNvSpPr/>
-          <p:nvPr/>
-        </p:nvSpPr>
-        <p:spPr>
-          <a:xfrm>
-            <a:off x="10326624" y="2084831"/>
-            <a:ext cx="1176527" cy="658368"/>
-          </a:xfrm>
-          <a:prstGeom prst="rect">
-            <a:avLst/>
-          </a:prstGeom>
-          <a:solidFill>
-            <a:srgbClr val="FFFFFF"/>
-          </a:solidFill>
-          <a:ln w="9525">
-            <a:solidFill>
-              <a:srgbClr val="9E9E9E"/>
-            </a:solidFill>
-          </a:ln>
-          <a:effectLst/>
-        </p:spPr>
-        <p:style>
-          <a:lnRef idx="1">
-            <a:schemeClr val="accent1"/>
-          </a:lnRef>
-          <a:fillRef idx="3">
-            <a:schemeClr val="accent1"/>
-          </a:fillRef>
-          <a:effectRef idx="2">
-            <a:schemeClr val="accent1"/>
-          </a:effectRef>
-          <a:fontRef idx="minor">
-            <a:schemeClr val="lt1"/>
-          </a:fontRef>
-        </p:style>
-        <p:txBody>
-          <a:bodyPr rtlCol="0" anchor="ctr"/>
-          <a:lstStyle/>
-          <a:p/>
-        </p:txBody>
-      </p:sp>
-      <p:sp>
-        <p:nvSpPr>
-          <p:cNvPr id="31" name="TextBox 30"/>
-          <p:cNvSpPr txBox="1"/>
-          <p:nvPr/>
-        </p:nvSpPr>
-        <p:spPr>
-          <a:xfrm>
-            <a:off x="10326624" y="2084831"/>
-            <a:ext cx="1176527" cy="658368"/>
-          </a:xfrm>
-          <a:prstGeom prst="rect">
-            <a:avLst/>
-          </a:prstGeom>
-          <a:noFill/>
-        </p:spPr>
-        <p:txBody>
-          <a:bodyPr wrap="square" lIns="18288" rIns="18288" tIns="10972" bIns="10972" anchor="ctr">
-            <a:spAutoFit/>
-          </a:bodyPr>
-          <a:lstStyle/>
-          <a:p>
-            <a:pPr algn="ctr">
-              <a:spcAft>
-                <a:spcPts val="0"/>
-              </a:spcAft>
-            </a:pPr>
-            <a:r>
-              <a:rPr sz="950" b="0" i="0">
-                <a:solidFill>
-                  <a:srgbClr val="111111"/>
-                </a:solidFill>
-                <a:latin typeface="Meiryo"/>
-                <a:ea typeface="Meiryo"/>
-                <a:cs typeface="Meiryo"/>
-              </a:rPr>
-              <a:t>自作
-アダプタ
-(逐次)</a:t>
-            </a:r>
-          </a:p>
-        </p:txBody>
-      </p:sp>
-      <p:sp>
-        <p:nvSpPr>
-          <p:cNvPr id="32" name="Rectangle 31"/>
-          <p:cNvSpPr/>
-          <p:nvPr/>
-        </p:nvSpPr>
-        <p:spPr>
-          <a:xfrm>
-            <a:off x="7790688" y="2834640"/>
-            <a:ext cx="3712463" cy="365760"/>
-          </a:xfrm>
-          <a:prstGeom prst="rect">
-            <a:avLst/>
-          </a:prstGeom>
-          <a:solidFill>
-            <a:srgbClr val="E8E8E8"/>
-          </a:solidFill>
-          <a:ln w="9525">
-            <a:solidFill>
-              <a:srgbClr val="9E9E9E"/>
-            </a:solidFill>
-          </a:ln>
-          <a:effectLst/>
-        </p:spPr>
-        <p:style>
-          <a:lnRef idx="1">
-            <a:schemeClr val="accent1"/>
-          </a:lnRef>
-          <a:fillRef idx="3">
-            <a:schemeClr val="accent1"/>
-          </a:fillRef>
-          <a:effectRef idx="2">
-            <a:schemeClr val="accent1"/>
-          </a:effectRef>
-          <a:fontRef idx="minor">
-            <a:schemeClr val="lt1"/>
-          </a:fontRef>
-        </p:style>
-        <p:txBody>
-          <a:bodyPr rtlCol="0" anchor="ctr"/>
-          <a:lstStyle/>
-          <a:p/>
-        </p:txBody>
-      </p:sp>
-      <p:sp>
-        <p:nvSpPr>
-          <p:cNvPr id="33" name="TextBox 32"/>
-          <p:cNvSpPr txBox="1"/>
-          <p:nvPr/>
-        </p:nvSpPr>
-        <p:spPr>
-          <a:xfrm>
-            <a:off x="7790688" y="2834640"/>
-            <a:ext cx="3712463" cy="365760"/>
-          </a:xfrm>
-          <a:prstGeom prst="rect">
-            <a:avLst/>
-          </a:prstGeom>
-          <a:noFill/>
-        </p:spPr>
-        <p:txBody>
-          <a:bodyPr wrap="square" lIns="27432" rIns="27432" tIns="16459" bIns="16459" anchor="ctr">
-            <a:spAutoFit/>
-          </a:bodyPr>
-          <a:lstStyle/>
-          <a:p>
-            <a:pPr algn="ctr">
-              <a:spcAft>
-                <a:spcPts val="400"/>
-              </a:spcAft>
-            </a:pPr>
-            <a:r>
-              <a:rPr sz="1150" b="1" i="0">
-                <a:solidFill>
-                  <a:srgbClr val="111111"/>
-                </a:solidFill>
-                <a:latin typeface="Meiryo"/>
-                <a:ea typeface="Meiryo"/>
-                <a:cs typeface="Meiryo"/>
-              </a:rPr>
-              <a:t>3 経路とも checksum=32768.000000 PASS</a:t>
-            </a:r>
-          </a:p>
-        </p:txBody>
-      </p:sp>
-      <p:sp>
-        <p:nvSpPr>
-          <p:cNvPr id="34" name="TextBox 33"/>
-          <p:cNvSpPr txBox="1"/>
-          <p:nvPr/>
-        </p:nvSpPr>
-        <p:spPr>
-          <a:xfrm>
-            <a:off x="7735824" y="3236976"/>
-            <a:ext cx="3822191" cy="347472"/>
+            <a:off x="502920" y="6199632"/>
+            <a:ext cx="11185855" cy="292608"/>
           </a:xfrm>
           <a:prstGeom prst="rect">
             <a:avLst/>
@@ -21699,13 +21286,13 @@
           </a:bodyPr>
           <a:lstStyle/>
           <a:p>
-            <a:pPr algn="ctr">
+            <a:pPr algn="l">
               <a:spcAft>
                 <a:spcPts val="400"/>
               </a:spcAft>
             </a:pPr>
             <a:r>
-              <a:rPr sz="1000" b="0" i="0">
+              <a:rPr sz="1150" b="0" i="0">
                 <a:solidFill>
                   <a:srgbClr val="5A5A5A"/>
                 </a:solidFill>
@@ -21713,256 +21300,14 @@
                 <a:ea typeface="Meiryo"/>
                 <a:cs typeface="Meiryo"/>
               </a:rPr>
-              <a:t>2 ランクのアダプタ経路はホストの pthread ハーネス (1,788 checks) が担保</a:t>
-            </a:r>
-          </a:p>
-        </p:txBody>
-      </p:sp>
-      <p:sp>
-        <p:nvSpPr>
-          <p:cNvPr id="35" name="Rectangle 34"/>
-          <p:cNvSpPr/>
-          <p:nvPr/>
-        </p:nvSpPr>
-        <p:spPr>
-          <a:xfrm>
-            <a:off x="7607808" y="3767328"/>
-            <a:ext cx="4078224" cy="1975104"/>
-          </a:xfrm>
-          <a:prstGeom prst="rect">
-            <a:avLst/>
-          </a:prstGeom>
-          <a:solidFill>
-            <a:srgbClr val="F4F4F4"/>
-          </a:solidFill>
-          <a:ln w="9525">
-            <a:solidFill>
-              <a:srgbClr val="9E9E9E"/>
-            </a:solidFill>
-          </a:ln>
-          <a:effectLst/>
-        </p:spPr>
-        <p:style>
-          <a:lnRef idx="1">
-            <a:schemeClr val="accent1"/>
-          </a:lnRef>
-          <a:fillRef idx="3">
-            <a:schemeClr val="accent1"/>
-          </a:fillRef>
-          <a:effectRef idx="2">
-            <a:schemeClr val="accent1"/>
-          </a:effectRef>
-          <a:fontRef idx="minor">
-            <a:schemeClr val="lt1"/>
-          </a:fontRef>
-        </p:style>
-        <p:txBody>
-          <a:bodyPr rtlCol="0" anchor="ctr"/>
-          <a:lstStyle/>
-          <a:p/>
-        </p:txBody>
-      </p:sp>
-      <p:sp>
-        <p:nvSpPr>
-          <p:cNvPr id="36" name="Rectangle 35"/>
-          <p:cNvSpPr/>
-          <p:nvPr/>
-        </p:nvSpPr>
-        <p:spPr>
-          <a:xfrm>
-            <a:off x="7607808" y="3767328"/>
-            <a:ext cx="4078224" cy="384048"/>
-          </a:xfrm>
-          <a:prstGeom prst="rect">
-            <a:avLst/>
-          </a:prstGeom>
-          <a:solidFill>
-            <a:srgbClr val="E8E8E8"/>
-          </a:solidFill>
-          <a:ln w="9525">
-            <a:solidFill>
-              <a:srgbClr val="9E9E9E"/>
-            </a:solidFill>
-          </a:ln>
-          <a:effectLst/>
-        </p:spPr>
-        <p:style>
-          <a:lnRef idx="1">
-            <a:schemeClr val="accent1"/>
-          </a:lnRef>
-          <a:fillRef idx="3">
-            <a:schemeClr val="accent1"/>
-          </a:fillRef>
-          <a:effectRef idx="2">
-            <a:schemeClr val="accent1"/>
-          </a:effectRef>
-          <a:fontRef idx="minor">
-            <a:schemeClr val="lt1"/>
-          </a:fontRef>
-        </p:style>
-        <p:txBody>
-          <a:bodyPr rtlCol="0" anchor="ctr"/>
-          <a:lstStyle/>
-          <a:p/>
-        </p:txBody>
-      </p:sp>
-      <p:sp>
-        <p:nvSpPr>
-          <p:cNvPr id="37" name="TextBox 36"/>
-          <p:cNvSpPr txBox="1"/>
-          <p:nvPr/>
-        </p:nvSpPr>
-        <p:spPr>
-          <a:xfrm>
-            <a:off x="7607808" y="3767328"/>
-            <a:ext cx="4078224" cy="384048"/>
-          </a:xfrm>
-          <a:prstGeom prst="rect">
-            <a:avLst/>
-          </a:prstGeom>
-          <a:noFill/>
-        </p:spPr>
-        <p:txBody>
-          <a:bodyPr wrap="square" lIns="109728" rIns="109728" tIns="65836" bIns="65836" anchor="ctr">
-            <a:spAutoFit/>
-          </a:bodyPr>
-          <a:lstStyle/>
-          <a:p>
-            <a:pPr algn="l">
-              <a:spcAft>
-                <a:spcPts val="400"/>
-              </a:spcAft>
-            </a:pPr>
-            <a:r>
-              <a:rPr sz="1400" b="1" i="0">
-                <a:solidFill>
-                  <a:srgbClr val="111111"/>
-                </a:solidFill>
-                <a:latin typeface="Meiryo"/>
-                <a:ea typeface="Meiryo"/>
-                <a:cs typeface="Meiryo"/>
-              </a:rPr>
-              <a:t>SDK に合わせるしかない制約</a:t>
-            </a:r>
-          </a:p>
-        </p:txBody>
-      </p:sp>
-      <p:sp>
-        <p:nvSpPr>
-          <p:cNvPr id="38" name="TextBox 37"/>
-          <p:cNvSpPr txBox="1"/>
-          <p:nvPr/>
-        </p:nvSpPr>
-        <p:spPr>
-          <a:xfrm>
-            <a:off x="7607808" y="4151376"/>
-            <a:ext cx="4078224" cy="1591056"/>
-          </a:xfrm>
-          <a:prstGeom prst="rect">
-            <a:avLst/>
-          </a:prstGeom>
-          <a:noFill/>
-        </p:spPr>
-        <p:txBody>
-          <a:bodyPr wrap="square" lIns="109728" rIns="109728" tIns="65836" bIns="65836" anchor="t">
-            <a:spAutoFit/>
-          </a:bodyPr>
-          <a:lstStyle/>
-          <a:p>
-            <a:pPr algn="l">
-              <a:spcAft>
-                <a:spcPts val="500"/>
-              </a:spcAft>
-            </a:pPr>
-            <a:r>
-              <a:rPr sz="1200" b="0" i="0">
-                <a:solidFill>
-                  <a:srgbClr val="111111"/>
-                </a:solidFill>
-                <a:latin typeface="Meiryo"/>
-                <a:ea typeface="Meiryo"/>
-                <a:cs typeface="Meiryo"/>
-              </a:rPr>
-              <a:t>・ -std=gnu++98 / -fno-exceptions / -fno-rtti</a:t>
-            </a:r>
-          </a:p>
-          <a:p>
-            <a:pPr algn="l">
-              <a:spcAft>
-                <a:spcPts val="700"/>
-              </a:spcAft>
-            </a:pPr>
-            <a:r>
-              <a:rPr sz="1100" b="0" i="0">
-                <a:solidFill>
-                  <a:srgbClr val="5A5A5A"/>
-                </a:solidFill>
-                <a:latin typeface="Meiryo"/>
-                <a:ea typeface="Meiryo"/>
-                <a:cs typeface="Meiryo"/>
-              </a:rPr>
-              <a:t>   → C++11 以降が使えない</a:t>
-            </a:r>
-          </a:p>
-          <a:p>
-            <a:pPr algn="l">
-              <a:spcAft>
-                <a:spcPts val="500"/>
-              </a:spcAft>
-            </a:pPr>
-            <a:r>
-              <a:rPr sz="1200" b="0" i="0">
-                <a:solidFill>
-                  <a:srgbClr val="111111"/>
-                </a:solidFill>
-                <a:latin typeface="Meiryo"/>
-                <a:ea typeface="Meiryo"/>
-                <a:cs typeface="Meiryo"/>
-              </a:rPr>
-              <a:t>・ ヒープ禁止・STL 禁止・静的バッファのみ</a:t>
-            </a:r>
-          </a:p>
-          <a:p>
-            <a:pPr algn="l">
-              <a:spcAft>
-                <a:spcPts val="500"/>
-              </a:spcAft>
-            </a:pPr>
-            <a:r>
-              <a:rPr sz="1200" b="0" i="0">
-                <a:solidFill>
-                  <a:srgbClr val="111111"/>
-                </a:solidFill>
-                <a:latin typeface="Meiryo"/>
-                <a:ea typeface="Meiryo"/>
-                <a:cs typeface="Meiryo"/>
-              </a:rPr>
-              <a:t>・ double 禁止 (単精度 FPU のみ)。リテラルは 1.0f</a:t>
-            </a:r>
-          </a:p>
-          <a:p>
-            <a:pPr algn="l">
-              <a:spcAft>
-                <a:spcPts val="0"/>
-              </a:spcAft>
-            </a:pPr>
-            <a:r>
-              <a:rPr sz="1200" b="0" i="0">
-                <a:solidFill>
-                  <a:srgbClr val="111111"/>
-                </a:solidFill>
-                <a:latin typeface="Meiryo"/>
-                <a:ea typeface="Meiryo"/>
-                <a:cs typeface="Meiryo"/>
-              </a:rPr>
-              <a:t>・ make check98 で機械的に担保</a:t>
-            </a:r>
-          </a:p>
-        </p:txBody>
-      </p:sp>
-      <p:sp>
-        <p:nvSpPr>
-          <p:cNvPr id="39" name="TextBox 38"/>
+              <a:t>規模: adapters 926 行 / firmware 統合 1,656 行 / tests 1,846 行 / 設計ドキュメント 2,643 行</a:t>
+            </a:r>
+          </a:p>
+        </p:txBody>
+      </p:sp>
+      <p:sp>
+        <p:nvSpPr>
+          <p:cNvPr id="25" name="TextBox 24"/>
           <p:cNvSpPr txBox="1"/>
           <p:nvPr/>
         </p:nvSpPr>

</xml_diff>

<commit_message>
feat(slides): show Claude Code on the development-environment slide
Placed as a band across the four lanes rather than a fifth lane, since it
drives all of them: SDK archaeology (disassembly, nm), the TDD split (Red
in the main session, Green delegated to a subagent), and watching the
device runs. Carries the commit trailer count as the evidence.

Co-Authored-By: Claude Opus 5 (1M context) <noreply@anthropic.com>
Claude-Session: https://claude.ai/code/session_01GfWBNUHfEor9QCWXsKfWWj
</commit_message>
<xml_diff>
--- a/slides/lt-ear-parallel.pptx
+++ b/slides/lt-ear-parallel.pptx
@@ -23215,7 +23215,7 @@
         <p:spPr>
           <a:xfrm>
             <a:off x="502920" y="1133856"/>
-            <a:ext cx="2659303" cy="2331720"/>
+            <a:ext cx="2659303" cy="2103120"/>
           </a:xfrm>
           <a:prstGeom prst="rect">
             <a:avLst/>
@@ -23385,7 +23385,7 @@
         <p:spPr>
           <a:xfrm>
             <a:off x="576072" y="1719072"/>
-            <a:ext cx="2512999" cy="1691640"/>
+            <a:ext cx="2512999" cy="1481328"/>
           </a:xfrm>
           <a:prstGeom prst="rect">
             <a:avLst/>
@@ -23498,7 +23498,7 @@
         <p:spPr>
           <a:xfrm>
             <a:off x="3345103" y="1133856"/>
-            <a:ext cx="2659303" cy="2331720"/>
+            <a:ext cx="2659303" cy="2103120"/>
           </a:xfrm>
           <a:prstGeom prst="rect">
             <a:avLst/>
@@ -23668,7 +23668,7 @@
         <p:spPr>
           <a:xfrm>
             <a:off x="3418255" y="1719072"/>
-            <a:ext cx="2512999" cy="1691640"/>
+            <a:ext cx="2512999" cy="1481328"/>
           </a:xfrm>
           <a:prstGeom prst="rect">
             <a:avLst/>
@@ -23781,7 +23781,7 @@
         <p:spPr>
           <a:xfrm>
             <a:off x="6187287" y="1133856"/>
-            <a:ext cx="2659303" cy="2331720"/>
+            <a:ext cx="2659303" cy="2103120"/>
           </a:xfrm>
           <a:prstGeom prst="rect">
             <a:avLst/>
@@ -23951,7 +23951,7 @@
         <p:spPr>
           <a:xfrm>
             <a:off x="6260439" y="1719072"/>
-            <a:ext cx="2512999" cy="1691640"/>
+            <a:ext cx="2512999" cy="1481328"/>
           </a:xfrm>
           <a:prstGeom prst="rect">
             <a:avLst/>
@@ -24064,7 +24064,7 @@
         <p:spPr>
           <a:xfrm>
             <a:off x="9029471" y="1133856"/>
-            <a:ext cx="2659303" cy="2331720"/>
+            <a:ext cx="2659303" cy="2103120"/>
           </a:xfrm>
           <a:prstGeom prst="rect">
             <a:avLst/>
@@ -24234,7 +24234,7 @@
         <p:spPr>
           <a:xfrm>
             <a:off x="9102623" y="1719072"/>
-            <a:ext cx="2512999" cy="1691640"/>
+            <a:ext cx="2512999" cy="1481328"/>
           </a:xfrm>
           <a:prstGeom prst="rect">
             <a:avLst/>
@@ -24346,8 +24346,465 @@
         </p:nvSpPr>
         <p:spPr>
           <a:xfrm>
-            <a:off x="502920" y="3675887"/>
-            <a:ext cx="11185855" cy="1883664"/>
+            <a:off x="502920" y="3346704"/>
+            <a:ext cx="11185855" cy="969264"/>
+          </a:xfrm>
+          <a:prstGeom prst="rect">
+            <a:avLst/>
+          </a:prstGeom>
+          <a:solidFill>
+            <a:srgbClr val="F3EFF9"/>
+          </a:solidFill>
+          <a:ln w="9525">
+            <a:solidFill>
+              <a:srgbClr val="9E9E9E"/>
+            </a:solidFill>
+          </a:ln>
+          <a:effectLst/>
+        </p:spPr>
+        <p:style>
+          <a:lnRef idx="1">
+            <a:schemeClr val="accent1"/>
+          </a:lnRef>
+          <a:fillRef idx="3">
+            <a:schemeClr val="accent1"/>
+          </a:fillRef>
+          <a:effectRef idx="2">
+            <a:schemeClr val="accent1"/>
+          </a:effectRef>
+          <a:fontRef idx="minor">
+            <a:schemeClr val="lt1"/>
+          </a:fontRef>
+        </p:style>
+        <p:txBody>
+          <a:bodyPr rtlCol="0" anchor="ctr"/>
+          <a:lstStyle/>
+          <a:p/>
+        </p:txBody>
+      </p:sp>
+      <p:sp>
+        <p:nvSpPr>
+          <p:cNvPr id="27" name="Rectangle 26"/>
+          <p:cNvSpPr/>
+          <p:nvPr/>
+        </p:nvSpPr>
+        <p:spPr>
+          <a:xfrm>
+            <a:off x="502920" y="3346704"/>
+            <a:ext cx="11185855" cy="384048"/>
+          </a:xfrm>
+          <a:prstGeom prst="rect">
+            <a:avLst/>
+          </a:prstGeom>
+          <a:solidFill>
+            <a:srgbClr val="E3DCF2"/>
+          </a:solidFill>
+          <a:ln w="9525">
+            <a:solidFill>
+              <a:srgbClr val="9E9E9E"/>
+            </a:solidFill>
+          </a:ln>
+          <a:effectLst/>
+        </p:spPr>
+        <p:style>
+          <a:lnRef idx="1">
+            <a:schemeClr val="accent1"/>
+          </a:lnRef>
+          <a:fillRef idx="3">
+            <a:schemeClr val="accent1"/>
+          </a:fillRef>
+          <a:effectRef idx="2">
+            <a:schemeClr val="accent1"/>
+          </a:effectRef>
+          <a:fontRef idx="minor">
+            <a:schemeClr val="lt1"/>
+          </a:fontRef>
+        </p:style>
+        <p:txBody>
+          <a:bodyPr rtlCol="0" anchor="ctr"/>
+          <a:lstStyle/>
+          <a:p/>
+        </p:txBody>
+      </p:sp>
+      <p:sp>
+        <p:nvSpPr>
+          <p:cNvPr id="28" name="TextBox 27"/>
+          <p:cNvSpPr txBox="1"/>
+          <p:nvPr/>
+        </p:nvSpPr>
+        <p:spPr>
+          <a:xfrm>
+            <a:off x="594360" y="3364992"/>
+            <a:ext cx="420624" cy="347472"/>
+          </a:xfrm>
+          <a:prstGeom prst="rect">
+            <a:avLst/>
+          </a:prstGeom>
+          <a:noFill/>
+        </p:spPr>
+        <p:txBody>
+          <a:bodyPr wrap="square" lIns="0" rIns="0" tIns="0" bIns="0" anchor="t">
+            <a:spAutoFit/>
+          </a:bodyPr>
+          <a:lstStyle/>
+          <a:p>
+            <a:pPr algn="l">
+              <a:spcAft>
+                <a:spcPts val="400"/>
+              </a:spcAft>
+            </a:pPr>
+            <a:r>
+              <a:rPr sz="1700" b="0" i="0">
+                <a:solidFill>
+                  <a:srgbClr val="111111"/>
+                </a:solidFill>
+                <a:latin typeface="Meiryo"/>
+                <a:ea typeface="Meiryo"/>
+                <a:cs typeface="Meiryo"/>
+              </a:rPr>
+              <a:t>🤖</a:t>
+            </a:r>
+          </a:p>
+        </p:txBody>
+      </p:sp>
+      <p:sp>
+        <p:nvSpPr>
+          <p:cNvPr id="29" name="TextBox 28"/>
+          <p:cNvSpPr txBox="1"/>
+          <p:nvPr/>
+        </p:nvSpPr>
+        <p:spPr>
+          <a:xfrm>
+            <a:off x="1033271" y="3346704"/>
+            <a:ext cx="5486400" cy="384048"/>
+          </a:xfrm>
+          <a:prstGeom prst="rect">
+            <a:avLst/>
+          </a:prstGeom>
+          <a:noFill/>
+        </p:spPr>
+        <p:txBody>
+          <a:bodyPr wrap="square" lIns="0" rIns="0" tIns="0" bIns="0" anchor="ctr">
+            <a:spAutoFit/>
+          </a:bodyPr>
+          <a:lstStyle/>
+          <a:p>
+            <a:pPr algn="l">
+              <a:spcAft>
+                <a:spcPts val="400"/>
+              </a:spcAft>
+            </a:pPr>
+            <a:r>
+              <a:rPr sz="1300" b="1" i="0">
+                <a:solidFill>
+                  <a:srgbClr val="111111"/>
+                </a:solidFill>
+                <a:latin typeface="Meiryo"/>
+                <a:ea typeface="Meiryo"/>
+                <a:cs typeface="Meiryo"/>
+              </a:rPr>
+              <a:t>Claude Code — 4 つの世界を横断して回す</a:t>
+            </a:r>
+          </a:p>
+        </p:txBody>
+      </p:sp>
+      <p:sp>
+        <p:nvSpPr>
+          <p:cNvPr id="30" name="TextBox 29"/>
+          <p:cNvSpPr txBox="1"/>
+          <p:nvPr/>
+        </p:nvSpPr>
+        <p:spPr>
+          <a:xfrm>
+            <a:off x="6933895" y="3346704"/>
+            <a:ext cx="4754880" cy="384048"/>
+          </a:xfrm>
+          <a:prstGeom prst="rect">
+            <a:avLst/>
+          </a:prstGeom>
+          <a:noFill/>
+        </p:spPr>
+        <p:txBody>
+          <a:bodyPr wrap="square" tIns="54864" bIns="54864" anchor="ctr">
+            <a:spAutoFit/>
+          </a:bodyPr>
+          <a:lstStyle/>
+          <a:p>
+            <a:pPr algn="r">
+              <a:spcAft>
+                <a:spcPts val="400"/>
+              </a:spcAft>
+            </a:pPr>
+            <a:r>
+              <a:rPr sz="1050" b="0" i="0">
+                <a:solidFill>
+                  <a:srgbClr val="5A5A5A"/>
+                </a:solidFill>
+                <a:latin typeface="Meiryo"/>
+                <a:ea typeface="Meiryo"/>
+                <a:cs typeface="Meiryo"/>
+              </a:rPr>
+              <a:t>103 コミット中 102 が Co-Authored-By: Claude</a:t>
+            </a:r>
+          </a:p>
+        </p:txBody>
+      </p:sp>
+      <p:sp>
+        <p:nvSpPr>
+          <p:cNvPr id="31" name="TextBox 30"/>
+          <p:cNvSpPr txBox="1"/>
+          <p:nvPr/>
+        </p:nvSpPr>
+        <p:spPr>
+          <a:xfrm>
+            <a:off x="685800" y="3785615"/>
+            <a:ext cx="3484778" cy="237744"/>
+          </a:xfrm>
+          <a:prstGeom prst="rect">
+            <a:avLst/>
+          </a:prstGeom>
+          <a:noFill/>
+        </p:spPr>
+        <p:txBody>
+          <a:bodyPr wrap="square" lIns="0" rIns="0" tIns="0" bIns="0" anchor="t">
+            <a:spAutoFit/>
+          </a:bodyPr>
+          <a:lstStyle/>
+          <a:p>
+            <a:pPr algn="l">
+              <a:spcAft>
+                <a:spcPts val="400"/>
+              </a:spcAft>
+            </a:pPr>
+            <a:r>
+              <a:rPr sz="1050" b="1" i="0">
+                <a:solidFill>
+                  <a:srgbClr val="111111"/>
+                </a:solidFill>
+                <a:latin typeface="Meiryo"/>
+                <a:ea typeface="Meiryo"/>
+                <a:cs typeface="Meiryo"/>
+              </a:rPr>
+              <a:t>・ 設計・SDK 調査</a:t>
+            </a:r>
+          </a:p>
+        </p:txBody>
+      </p:sp>
+      <p:sp>
+        <p:nvSpPr>
+          <p:cNvPr id="32" name="TextBox 31"/>
+          <p:cNvSpPr txBox="1"/>
+          <p:nvPr/>
+        </p:nvSpPr>
+        <p:spPr>
+          <a:xfrm>
+            <a:off x="832104" y="4023360"/>
+            <a:ext cx="3338474" cy="256032"/>
+          </a:xfrm>
+          <a:prstGeom prst="rect">
+            <a:avLst/>
+          </a:prstGeom>
+          <a:noFill/>
+        </p:spPr>
+        <p:txBody>
+          <a:bodyPr wrap="square" lIns="0" rIns="0" tIns="0" bIns="0" anchor="t">
+            <a:spAutoFit/>
+          </a:bodyPr>
+          <a:lstStyle/>
+          <a:p>
+            <a:pPr algn="l">
+              <a:spcAft>
+                <a:spcPts val="400"/>
+              </a:spcAft>
+            </a:pPr>
+            <a:r>
+              <a:rPr sz="950" b="0" i="0">
+                <a:solidFill>
+                  <a:srgbClr val="5A5A5A"/>
+                </a:solidFill>
+                <a:latin typeface="Meiryo"/>
+                <a:ea typeface="Meiryo"/>
+                <a:cs typeface="Meiryo"/>
+              </a:rPr>
+              <a:t>プリビルト .a の逆アセンブルと nm でのシンボル解決</a:t>
+            </a:r>
+          </a:p>
+        </p:txBody>
+      </p:sp>
+      <p:sp>
+        <p:nvSpPr>
+          <p:cNvPr id="33" name="TextBox 32"/>
+          <p:cNvSpPr txBox="1"/>
+          <p:nvPr/>
+        </p:nvSpPr>
+        <p:spPr>
+          <a:xfrm>
+            <a:off x="4353458" y="3785615"/>
+            <a:ext cx="3484778" cy="237744"/>
+          </a:xfrm>
+          <a:prstGeom prst="rect">
+            <a:avLst/>
+          </a:prstGeom>
+          <a:noFill/>
+        </p:spPr>
+        <p:txBody>
+          <a:bodyPr wrap="square" lIns="0" rIns="0" tIns="0" bIns="0" anchor="t">
+            <a:spAutoFit/>
+          </a:bodyPr>
+          <a:lstStyle/>
+          <a:p>
+            <a:pPr algn="l">
+              <a:spcAft>
+                <a:spcPts val="400"/>
+              </a:spcAft>
+            </a:pPr>
+            <a:r>
+              <a:rPr sz="1050" b="1" i="0">
+                <a:solidFill>
+                  <a:srgbClr val="111111"/>
+                </a:solidFill>
+                <a:latin typeface="Meiryo"/>
+                <a:ea typeface="Meiryo"/>
+                <a:cs typeface="Meiryo"/>
+              </a:rPr>
+              <a:t>・ TDD の運用</a:t>
+            </a:r>
+          </a:p>
+        </p:txBody>
+      </p:sp>
+      <p:sp>
+        <p:nvSpPr>
+          <p:cNvPr id="34" name="TextBox 33"/>
+          <p:cNvSpPr txBox="1"/>
+          <p:nvPr/>
+        </p:nvSpPr>
+        <p:spPr>
+          <a:xfrm>
+            <a:off x="4499762" y="4023360"/>
+            <a:ext cx="3338474" cy="256032"/>
+          </a:xfrm>
+          <a:prstGeom prst="rect">
+            <a:avLst/>
+          </a:prstGeom>
+          <a:noFill/>
+        </p:spPr>
+        <p:txBody>
+          <a:bodyPr wrap="square" lIns="0" rIns="0" tIns="0" bIns="0" anchor="t">
+            <a:spAutoFit/>
+          </a:bodyPr>
+          <a:lstStyle/>
+          <a:p>
+            <a:pPr algn="l">
+              <a:spcAft>
+                <a:spcPts val="400"/>
+              </a:spcAft>
+            </a:pPr>
+            <a:r>
+              <a:rPr sz="950" b="0" i="0">
+                <a:solidFill>
+                  <a:srgbClr val="5A5A5A"/>
+                </a:solidFill>
+                <a:latin typeface="Meiryo"/>
+                <a:ea typeface="Meiryo"/>
+                <a:cs typeface="Meiryo"/>
+              </a:rPr>
+              <a:t>Red のテストは本体、Green の実装はサブエージェントへ</a:t>
+            </a:r>
+          </a:p>
+        </p:txBody>
+      </p:sp>
+      <p:sp>
+        <p:nvSpPr>
+          <p:cNvPr id="35" name="TextBox 34"/>
+          <p:cNvSpPr txBox="1"/>
+          <p:nvPr/>
+        </p:nvSpPr>
+        <p:spPr>
+          <a:xfrm>
+            <a:off x="8021116" y="3785615"/>
+            <a:ext cx="3484778" cy="237744"/>
+          </a:xfrm>
+          <a:prstGeom prst="rect">
+            <a:avLst/>
+          </a:prstGeom>
+          <a:noFill/>
+        </p:spPr>
+        <p:txBody>
+          <a:bodyPr wrap="square" lIns="0" rIns="0" tIns="0" bIns="0" anchor="t">
+            <a:spAutoFit/>
+          </a:bodyPr>
+          <a:lstStyle/>
+          <a:p>
+            <a:pPr algn="l">
+              <a:spcAft>
+                <a:spcPts val="400"/>
+              </a:spcAft>
+            </a:pPr>
+            <a:r>
+              <a:rPr sz="1050" b="1" i="0">
+                <a:solidFill>
+                  <a:srgbClr val="111111"/>
+                </a:solidFill>
+                <a:latin typeface="Meiryo"/>
+                <a:ea typeface="Meiryo"/>
+                <a:cs typeface="Meiryo"/>
+              </a:rPr>
+              <a:t>・ 実機ランの監視</a:t>
+            </a:r>
+          </a:p>
+        </p:txBody>
+      </p:sp>
+      <p:sp>
+        <p:nvSpPr>
+          <p:cNvPr id="36" name="TextBox 35"/>
+          <p:cNvSpPr txBox="1"/>
+          <p:nvPr/>
+        </p:nvSpPr>
+        <p:spPr>
+          <a:xfrm>
+            <a:off x="8167420" y="4023360"/>
+            <a:ext cx="3338474" cy="256032"/>
+          </a:xfrm>
+          <a:prstGeom prst="rect">
+            <a:avLst/>
+          </a:prstGeom>
+          <a:noFill/>
+        </p:spPr>
+        <p:txBody>
+          <a:bodyPr wrap="square" lIns="0" rIns="0" tIns="0" bIns="0" anchor="t">
+            <a:spAutoFit/>
+          </a:bodyPr>
+          <a:lstStyle/>
+          <a:p>
+            <a:pPr algn="l">
+              <a:spcAft>
+                <a:spcPts val="400"/>
+              </a:spcAft>
+            </a:pPr>
+            <a:r>
+              <a:rPr sz="950" b="0" i="0">
+                <a:solidFill>
+                  <a:srgbClr val="5A5A5A"/>
+                </a:solidFill>
+                <a:latin typeface="Meiryo"/>
+                <a:ea typeface="Meiryo"/>
+                <a:cs typeface="Meiryo"/>
+              </a:rPr>
+              <a:t>UART / SPP を監視し、結果を設計ドキュメントに反映</a:t>
+            </a:r>
+          </a:p>
+        </p:txBody>
+      </p:sp>
+      <p:sp>
+        <p:nvSpPr>
+          <p:cNvPr id="37" name="Rectangle 36"/>
+          <p:cNvSpPr/>
+          <p:nvPr/>
+        </p:nvSpPr>
+        <p:spPr>
+          <a:xfrm>
+            <a:off x="502920" y="4462272"/>
+            <a:ext cx="11185855" cy="1554480"/>
           </a:xfrm>
           <a:prstGeom prst="rect">
             <a:avLst/>
@@ -24384,14 +24841,14 @@
       </p:sp>
       <p:sp>
         <p:nvSpPr>
-          <p:cNvPr id="27" name="Rectangle 26"/>
+          <p:cNvPr id="38" name="Rectangle 37"/>
           <p:cNvSpPr/>
           <p:nvPr/>
         </p:nvSpPr>
         <p:spPr>
           <a:xfrm>
-            <a:off x="502920" y="3675887"/>
-            <a:ext cx="11185855" cy="402336"/>
+            <a:off x="502920" y="4462272"/>
+            <a:ext cx="11185855" cy="384048"/>
           </a:xfrm>
           <a:prstGeom prst="rect">
             <a:avLst/>
@@ -24428,14 +24885,14 @@
       </p:sp>
       <p:sp>
         <p:nvSpPr>
-          <p:cNvPr id="28" name="TextBox 27"/>
+          <p:cNvPr id="39" name="TextBox 38"/>
           <p:cNvSpPr txBox="1"/>
           <p:nvPr/>
         </p:nvSpPr>
         <p:spPr>
           <a:xfrm>
-            <a:off x="502920" y="3675887"/>
-            <a:ext cx="11185855" cy="402336"/>
+            <a:off x="502920" y="4462272"/>
+            <a:ext cx="11185855" cy="384048"/>
           </a:xfrm>
           <a:prstGeom prst="rect">
             <a:avLst/>
@@ -24454,7 +24911,7 @@
               </a:spcAft>
             </a:pPr>
             <a:r>
-              <a:rPr sz="1350" b="1" i="0">
+              <a:rPr sz="1300" b="1" i="0">
                 <a:solidFill>
                   <a:srgbClr val="111111"/>
                 </a:solidFill>
@@ -24469,14 +24926,14 @@
       </p:sp>
       <p:sp>
         <p:nvSpPr>
-          <p:cNvPr id="29" name="Rectangle 28"/>
+          <p:cNvPr id="40" name="Rectangle 39"/>
           <p:cNvSpPr/>
           <p:nvPr/>
         </p:nvSpPr>
         <p:spPr>
           <a:xfrm>
-            <a:off x="777240" y="4261104"/>
-            <a:ext cx="1544269" cy="676656"/>
+            <a:off x="777240" y="4956048"/>
+            <a:ext cx="1544269" cy="566928"/>
           </a:xfrm>
           <a:prstGeom prst="rect">
             <a:avLst/>
@@ -24513,14 +24970,14 @@
       </p:sp>
       <p:sp>
         <p:nvSpPr>
-          <p:cNvPr id="30" name="TextBox 29"/>
+          <p:cNvPr id="41" name="TextBox 40"/>
           <p:cNvSpPr txBox="1"/>
           <p:nvPr/>
         </p:nvSpPr>
         <p:spPr>
           <a:xfrm>
-            <a:off x="777240" y="4261104"/>
-            <a:ext cx="1544269" cy="676656"/>
+            <a:off x="777240" y="4956048"/>
+            <a:ext cx="1544269" cy="566928"/>
           </a:xfrm>
           <a:prstGeom prst="rect">
             <a:avLst/>
@@ -24539,7 +24996,7 @@
               </a:spcAft>
             </a:pPr>
             <a:r>
-              <a:rPr sz="1300" b="1" i="0">
+              <a:rPr sz="1250" b="1" i="0">
                 <a:solidFill>
                   <a:srgbClr val="111111"/>
                 </a:solidFill>
@@ -24554,13 +25011,13 @@
       </p:sp>
       <p:sp>
         <p:nvSpPr>
-          <p:cNvPr id="31" name="Right Arrow 30"/>
+          <p:cNvPr id="42" name="Right Arrow 41"/>
           <p:cNvSpPr/>
           <p:nvPr/>
         </p:nvSpPr>
         <p:spPr>
           <a:xfrm>
-            <a:off x="2339797" y="4462272"/>
+            <a:off x="2339797" y="5102352"/>
             <a:ext cx="237744" cy="274320"/>
           </a:xfrm>
           <a:prstGeom prst="rightArrow">
@@ -24598,14 +25055,14 @@
       </p:sp>
       <p:sp>
         <p:nvSpPr>
-          <p:cNvPr id="32" name="Rectangle 31"/>
+          <p:cNvPr id="43" name="Rectangle 42"/>
           <p:cNvSpPr/>
           <p:nvPr/>
         </p:nvSpPr>
         <p:spPr>
           <a:xfrm>
-            <a:off x="2595829" y="4261104"/>
-            <a:ext cx="1544269" cy="676656"/>
+            <a:off x="2595829" y="4956048"/>
+            <a:ext cx="1544269" cy="566928"/>
           </a:xfrm>
           <a:prstGeom prst="rect">
             <a:avLst/>
@@ -24642,14 +25099,14 @@
       </p:sp>
       <p:sp>
         <p:nvSpPr>
-          <p:cNvPr id="33" name="TextBox 32"/>
+          <p:cNvPr id="44" name="TextBox 43"/>
           <p:cNvSpPr txBox="1"/>
           <p:nvPr/>
         </p:nvSpPr>
         <p:spPr>
           <a:xfrm>
-            <a:off x="2595829" y="4261104"/>
-            <a:ext cx="1544269" cy="676656"/>
+            <a:off x="2595829" y="4956048"/>
+            <a:ext cx="1544269" cy="566928"/>
           </a:xfrm>
           <a:prstGeom prst="rect">
             <a:avLst/>
@@ -24668,7 +25125,7 @@
               </a:spcAft>
             </a:pPr>
             <a:r>
-              <a:rPr sz="1300" b="1" i="0">
+              <a:rPr sz="1250" b="1" i="0">
                 <a:solidFill>
                   <a:srgbClr val="111111"/>
                 </a:solidFill>
@@ -24683,13 +25140,13 @@
       </p:sp>
       <p:sp>
         <p:nvSpPr>
-          <p:cNvPr id="34" name="Right Arrow 33"/>
+          <p:cNvPr id="45" name="Right Arrow 44"/>
           <p:cNvSpPr/>
           <p:nvPr/>
         </p:nvSpPr>
         <p:spPr>
           <a:xfrm>
-            <a:off x="4158386" y="4462272"/>
+            <a:off x="4158386" y="5102352"/>
             <a:ext cx="237744" cy="274320"/>
           </a:xfrm>
           <a:prstGeom prst="rightArrow">
@@ -24727,14 +25184,14 @@
       </p:sp>
       <p:sp>
         <p:nvSpPr>
-          <p:cNvPr id="35" name="Rectangle 34"/>
+          <p:cNvPr id="46" name="Rectangle 45"/>
           <p:cNvSpPr/>
           <p:nvPr/>
         </p:nvSpPr>
         <p:spPr>
           <a:xfrm>
-            <a:off x="4414418" y="4261104"/>
-            <a:ext cx="1544269" cy="676656"/>
+            <a:off x="4414418" y="4956048"/>
+            <a:ext cx="1544269" cy="566928"/>
           </a:xfrm>
           <a:prstGeom prst="rect">
             <a:avLst/>
@@ -24771,14 +25228,14 @@
       </p:sp>
       <p:sp>
         <p:nvSpPr>
-          <p:cNvPr id="36" name="TextBox 35"/>
+          <p:cNvPr id="47" name="TextBox 46"/>
           <p:cNvSpPr txBox="1"/>
           <p:nvPr/>
         </p:nvSpPr>
         <p:spPr>
           <a:xfrm>
-            <a:off x="4414418" y="4261104"/>
-            <a:ext cx="1544269" cy="676656"/>
+            <a:off x="4414418" y="4956048"/>
+            <a:ext cx="1544269" cy="566928"/>
           </a:xfrm>
           <a:prstGeom prst="rect">
             <a:avLst/>
@@ -24797,7 +25254,7 @@
               </a:spcAft>
             </a:pPr>
             <a:r>
-              <a:rPr sz="1300" b="1" i="0">
+              <a:rPr sz="1250" b="1" i="0">
                 <a:solidFill>
                   <a:srgbClr val="111111"/>
                 </a:solidFill>
@@ -24812,13 +25269,13 @@
       </p:sp>
       <p:sp>
         <p:nvSpPr>
-          <p:cNvPr id="37" name="Right Arrow 36"/>
+          <p:cNvPr id="48" name="Right Arrow 47"/>
           <p:cNvSpPr/>
           <p:nvPr/>
         </p:nvSpPr>
         <p:spPr>
           <a:xfrm>
-            <a:off x="5976975" y="4462272"/>
+            <a:off x="5976975" y="5102352"/>
             <a:ext cx="237744" cy="274320"/>
           </a:xfrm>
           <a:prstGeom prst="rightArrow">
@@ -24856,14 +25313,14 @@
       </p:sp>
       <p:sp>
         <p:nvSpPr>
-          <p:cNvPr id="38" name="Rectangle 37"/>
+          <p:cNvPr id="49" name="Rectangle 48"/>
           <p:cNvSpPr/>
           <p:nvPr/>
         </p:nvSpPr>
         <p:spPr>
           <a:xfrm>
-            <a:off x="6233007" y="4261104"/>
-            <a:ext cx="1544269" cy="676656"/>
+            <a:off x="6233007" y="4956048"/>
+            <a:ext cx="1544269" cy="566928"/>
           </a:xfrm>
           <a:prstGeom prst="rect">
             <a:avLst/>
@@ -24900,14 +25357,14 @@
       </p:sp>
       <p:sp>
         <p:nvSpPr>
-          <p:cNvPr id="39" name="TextBox 38"/>
+          <p:cNvPr id="50" name="TextBox 49"/>
           <p:cNvSpPr txBox="1"/>
           <p:nvPr/>
         </p:nvSpPr>
         <p:spPr>
           <a:xfrm>
-            <a:off x="6233007" y="4261104"/>
-            <a:ext cx="1544269" cy="676656"/>
+            <a:off x="6233007" y="4956048"/>
+            <a:ext cx="1544269" cy="566928"/>
           </a:xfrm>
           <a:prstGeom prst="rect">
             <a:avLst/>
@@ -24926,7 +25383,7 @@
               </a:spcAft>
             </a:pPr>
             <a:r>
-              <a:rPr sz="1300" b="1" i="0">
+              <a:rPr sz="1250" b="1" i="0">
                 <a:solidFill>
                   <a:srgbClr val="111111"/>
                 </a:solidFill>
@@ -24941,13 +25398,13 @@
       </p:sp>
       <p:sp>
         <p:nvSpPr>
-          <p:cNvPr id="40" name="Right Arrow 39"/>
+          <p:cNvPr id="51" name="Right Arrow 50"/>
           <p:cNvSpPr/>
           <p:nvPr/>
         </p:nvSpPr>
         <p:spPr>
           <a:xfrm>
-            <a:off x="7795564" y="4462272"/>
+            <a:off x="7795564" y="5102352"/>
             <a:ext cx="237744" cy="274320"/>
           </a:xfrm>
           <a:prstGeom prst="rightArrow">
@@ -24985,14 +25442,14 @@
       </p:sp>
       <p:sp>
         <p:nvSpPr>
-          <p:cNvPr id="41" name="Rectangle 40"/>
+          <p:cNvPr id="52" name="Rectangle 51"/>
           <p:cNvSpPr/>
           <p:nvPr/>
         </p:nvSpPr>
         <p:spPr>
           <a:xfrm>
-            <a:off x="8051596" y="4261104"/>
-            <a:ext cx="1544269" cy="676656"/>
+            <a:off x="8051596" y="4956048"/>
+            <a:ext cx="1544269" cy="566928"/>
           </a:xfrm>
           <a:prstGeom prst="rect">
             <a:avLst/>
@@ -25029,14 +25486,14 @@
       </p:sp>
       <p:sp>
         <p:nvSpPr>
-          <p:cNvPr id="42" name="TextBox 41"/>
+          <p:cNvPr id="53" name="TextBox 52"/>
           <p:cNvSpPr txBox="1"/>
           <p:nvPr/>
         </p:nvSpPr>
         <p:spPr>
           <a:xfrm>
-            <a:off x="8051596" y="4261104"/>
-            <a:ext cx="1544269" cy="676656"/>
+            <a:off x="8051596" y="4956048"/>
+            <a:ext cx="1544269" cy="566928"/>
           </a:xfrm>
           <a:prstGeom prst="rect">
             <a:avLst/>
@@ -25055,7 +25512,7 @@
               </a:spcAft>
             </a:pPr>
             <a:r>
-              <a:rPr sz="1300" b="1" i="0">
+              <a:rPr sz="1250" b="1" i="0">
                 <a:solidFill>
                   <a:srgbClr val="111111"/>
                 </a:solidFill>
@@ -25070,13 +25527,13 @@
       </p:sp>
       <p:sp>
         <p:nvSpPr>
-          <p:cNvPr id="43" name="Right Arrow 42"/>
+          <p:cNvPr id="54" name="Right Arrow 53"/>
           <p:cNvSpPr/>
           <p:nvPr/>
         </p:nvSpPr>
         <p:spPr>
           <a:xfrm>
-            <a:off x="9614154" y="4462272"/>
+            <a:off x="9614154" y="5102352"/>
             <a:ext cx="237744" cy="274320"/>
           </a:xfrm>
           <a:prstGeom prst="rightArrow">
@@ -25114,14 +25571,14 @@
       </p:sp>
       <p:sp>
         <p:nvSpPr>
-          <p:cNvPr id="44" name="Rectangle 43"/>
+          <p:cNvPr id="55" name="Rectangle 54"/>
           <p:cNvSpPr/>
           <p:nvPr/>
         </p:nvSpPr>
         <p:spPr>
           <a:xfrm>
-            <a:off x="9870186" y="4261104"/>
-            <a:ext cx="1544269" cy="676656"/>
+            <a:off x="9870186" y="4956048"/>
+            <a:ext cx="1544269" cy="566928"/>
           </a:xfrm>
           <a:prstGeom prst="rect">
             <a:avLst/>
@@ -25158,14 +25615,14 @@
       </p:sp>
       <p:sp>
         <p:nvSpPr>
-          <p:cNvPr id="45" name="TextBox 44"/>
+          <p:cNvPr id="56" name="TextBox 55"/>
           <p:cNvSpPr txBox="1"/>
           <p:nvPr/>
         </p:nvSpPr>
         <p:spPr>
           <a:xfrm>
-            <a:off x="9870186" y="4261104"/>
-            <a:ext cx="1544269" cy="676656"/>
+            <a:off x="9870186" y="4956048"/>
+            <a:ext cx="1544269" cy="566928"/>
           </a:xfrm>
           <a:prstGeom prst="rect">
             <a:avLst/>
@@ -25184,7 +25641,7 @@
               </a:spcAft>
             </a:pPr>
             <a:r>
-              <a:rPr sz="1300" b="1" i="0">
+              <a:rPr sz="1250" b="1" i="0">
                 <a:solidFill>
                   <a:srgbClr val="111111"/>
                 </a:solidFill>
@@ -25199,14 +25656,14 @@
       </p:sp>
       <p:sp>
         <p:nvSpPr>
-          <p:cNvPr id="46" name="TextBox 45"/>
+          <p:cNvPr id="57" name="TextBox 56"/>
           <p:cNvSpPr txBox="1"/>
           <p:nvPr/>
         </p:nvSpPr>
         <p:spPr>
           <a:xfrm>
-            <a:off x="502920" y="5084064"/>
-            <a:ext cx="11185855" cy="329184"/>
+            <a:off x="502920" y="5614416"/>
+            <a:ext cx="11185855" cy="310896"/>
           </a:xfrm>
           <a:prstGeom prst="rect">
             <a:avLst/>
@@ -25240,14 +25697,14 @@
       </p:sp>
       <p:sp>
         <p:nvSpPr>
-          <p:cNvPr id="47" name="TextBox 46"/>
+          <p:cNvPr id="58" name="TextBox 57"/>
           <p:cNvSpPr txBox="1"/>
           <p:nvPr/>
         </p:nvSpPr>
         <p:spPr>
           <a:xfrm>
-            <a:off x="502920" y="5760720"/>
-            <a:ext cx="11185855" cy="365760"/>
+            <a:off x="502920" y="6089904"/>
+            <a:ext cx="11185855" cy="347472"/>
           </a:xfrm>
           <a:prstGeom prst="rect">
             <a:avLst/>
@@ -25266,7 +25723,7 @@
               </a:spcAft>
             </a:pPr>
             <a:r>
-              <a:rPr sz="1400" b="1" i="0">
+              <a:rPr sz="1350" b="1" i="0">
                 <a:solidFill>
                   <a:srgbClr val="111111"/>
                 </a:solidFill>

</xml_diff>

<commit_message>
feat(slides): put the session's time, cost, and commit count on the deck
Three figures aggregated from the Claude Code session transcripts in
~/.claude/projects (61 jsonl files, deduplicated by message id): 14 hours of
active work, $480 at published API rates, 103 commits.

The dollar figure is a conversion, not a bill: token counts times the public
per-MTok rates, with cache reads at 0.1x and writes at 1.25x (5m) / 2x (1h).
83% of it is prompt cache, which the markdown records alongside the per-model
split and the fact that 9/1 alone accounts for two thirds of both time and
spend.

The cycle note moves to the speaker notes to make room.

Co-Authored-By: Claude Opus 5 (1M context) <noreply@anthropic.com>
Claude-Session: https://claude.ai/code/session_01GfWBNUHfEor9QCWXsKfWWj
</commit_message>
<xml_diff>
--- a/slides/lt-ear-parallel.pptx
+++ b/slides/lt-ear-parallel.pptx
@@ -1497,7 +1497,7 @@
           <a:lstStyle/>
           <a:p>
             <a:r>
-              <a:t>4 つの世界をまたがないと 1 回も試せない、という絵。「WSL の中の Docker の中の GCC で焼いて、Windows の Python で受ける」で笑いが取れる。</a:t>
+              <a:t>4 つの世界をまたがないと 1 回も試せない、という絵。「WSL の中の Docker の中の GCC で焼いて、Windows の Python で受ける」で笑いが取れる。② が緑にならないうちは ④ に進まない — 焼いてから気づくと左右 2 個ぶんやり直し、は口頭で。$480 はセッションログのトークン数 × 公開単価の換算値で、実際の請求額ではない。</a:t>
             </a:r>
           </a:p>
         </p:txBody>
@@ -21867,7 +21867,7 @@
         <p:spPr>
           <a:xfrm>
             <a:off x="502920" y="1133856"/>
-            <a:ext cx="2659303" cy="1956816"/>
+            <a:ext cx="2659303" cy="1847088"/>
           </a:xfrm>
           <a:prstGeom prst="rect">
             <a:avLst/>
@@ -22037,7 +22037,7 @@
         <p:spPr>
           <a:xfrm>
             <a:off x="576072" y="1755648"/>
-            <a:ext cx="2512999" cy="1280160"/>
+            <a:ext cx="2512999" cy="1170432"/>
           </a:xfrm>
           <a:prstGeom prst="rect">
             <a:avLst/>
@@ -22114,7 +22114,7 @@
         <p:spPr>
           <a:xfrm>
             <a:off x="3345103" y="1133856"/>
-            <a:ext cx="2659303" cy="1956816"/>
+            <a:ext cx="2659303" cy="1847088"/>
           </a:xfrm>
           <a:prstGeom prst="rect">
             <a:avLst/>
@@ -22284,7 +22284,7 @@
         <p:spPr>
           <a:xfrm>
             <a:off x="3418255" y="1755648"/>
-            <a:ext cx="2512999" cy="1280160"/>
+            <a:ext cx="2512999" cy="1170432"/>
           </a:xfrm>
           <a:prstGeom prst="rect">
             <a:avLst/>
@@ -22361,7 +22361,7 @@
         <p:spPr>
           <a:xfrm>
             <a:off x="6187287" y="1133856"/>
-            <a:ext cx="2659303" cy="1956816"/>
+            <a:ext cx="2659303" cy="1847088"/>
           </a:xfrm>
           <a:prstGeom prst="rect">
             <a:avLst/>
@@ -22531,7 +22531,7 @@
         <p:spPr>
           <a:xfrm>
             <a:off x="6260439" y="1755648"/>
-            <a:ext cx="2512999" cy="1280160"/>
+            <a:ext cx="2512999" cy="1170432"/>
           </a:xfrm>
           <a:prstGeom prst="rect">
             <a:avLst/>
@@ -22608,7 +22608,7 @@
         <p:spPr>
           <a:xfrm>
             <a:off x="9029471" y="1133856"/>
-            <a:ext cx="2659303" cy="1956816"/>
+            <a:ext cx="2659303" cy="1847088"/>
           </a:xfrm>
           <a:prstGeom prst="rect">
             <a:avLst/>
@@ -22778,7 +22778,7 @@
         <p:spPr>
           <a:xfrm>
             <a:off x="9102623" y="1755648"/>
-            <a:ext cx="2512999" cy="1280160"/>
+            <a:ext cx="2512999" cy="1170432"/>
           </a:xfrm>
           <a:prstGeom prst="rect">
             <a:avLst/>
@@ -22854,8 +22854,8 @@
         </p:nvSpPr>
         <p:spPr>
           <a:xfrm>
-            <a:off x="502920" y="3236976"/>
-            <a:ext cx="11185855" cy="1005840"/>
+            <a:off x="502920" y="3108960"/>
+            <a:ext cx="11185855" cy="1682496"/>
           </a:xfrm>
           <a:prstGeom prst="rect">
             <a:avLst/>
@@ -22898,7 +22898,7 @@
         </p:nvSpPr>
         <p:spPr>
           <a:xfrm>
-            <a:off x="502920" y="3236976"/>
+            <a:off x="502920" y="3108960"/>
             <a:ext cx="11185855" cy="438912"/>
           </a:xfrm>
           <a:prstGeom prst="rect">
@@ -22942,7 +22942,7 @@
         </p:nvSpPr>
         <p:spPr>
           <a:xfrm>
-            <a:off x="594360" y="3255264"/>
+            <a:off x="594360" y="3127248"/>
             <a:ext cx="457200" cy="402336"/>
           </a:xfrm>
           <a:prstGeom prst="rect">
@@ -22983,8 +22983,8 @@
         </p:nvSpPr>
         <p:spPr>
           <a:xfrm>
-            <a:off x="1088136" y="3236976"/>
-            <a:ext cx="5852160" cy="438912"/>
+            <a:off x="1088136" y="3108960"/>
+            <a:ext cx="7315200" cy="438912"/>
           </a:xfrm>
           <a:prstGeom prst="rect">
             <a:avLst/>
@@ -23024,48 +23024,7 @@
         </p:nvSpPr>
         <p:spPr>
           <a:xfrm>
-            <a:off x="6751015" y="3236976"/>
-            <a:ext cx="4937760" cy="438912"/>
-          </a:xfrm>
-          <a:prstGeom prst="rect">
-            <a:avLst/>
-          </a:prstGeom>
-          <a:noFill/>
-        </p:spPr>
-        <p:txBody>
-          <a:bodyPr wrap="square" lIns="109728" rIns="109728" tIns="65836" bIns="65836" anchor="ctr">
-            <a:spAutoFit/>
-          </a:bodyPr>
-          <a:lstStyle/>
-          <a:p>
-            <a:pPr algn="r">
-              <a:spcAft>
-                <a:spcPts val="500"/>
-              </a:spcAft>
-            </a:pPr>
-            <a:r>
-              <a:rPr sz="1200" b="0" i="0">
-                <a:solidFill>
-                  <a:srgbClr val="4A4A4A"/>
-                </a:solidFill>
-                <a:latin typeface="Meiryo"/>
-                <a:ea typeface="Meiryo"/>
-                <a:cs typeface="Meiryo"/>
-              </a:rPr>
-              <a:t>103 コミット中 102 が Co-Authored-By: Claude</a:t>
-            </a:r>
-          </a:p>
-        </p:txBody>
-      </p:sp>
-      <p:sp>
-        <p:nvSpPr>
-          <p:cNvPr id="31" name="TextBox 30"/>
-          <p:cNvSpPr txBox="1"/>
-          <p:nvPr/>
-        </p:nvSpPr>
-        <p:spPr>
-          <a:xfrm>
-            <a:off x="685800" y="3712463"/>
+            <a:off x="685800" y="3602736"/>
             <a:ext cx="3484778" cy="256032"/>
           </a:xfrm>
           <a:prstGeom prst="rect">
@@ -23100,13 +23059,13 @@
       </p:sp>
       <p:sp>
         <p:nvSpPr>
-          <p:cNvPr id="32" name="TextBox 31"/>
+          <p:cNvPr id="31" name="TextBox 30"/>
           <p:cNvSpPr txBox="1"/>
           <p:nvPr/>
         </p:nvSpPr>
         <p:spPr>
           <a:xfrm>
-            <a:off x="868680" y="3950208"/>
+            <a:off x="868680" y="3822191"/>
             <a:ext cx="3301898" cy="256032"/>
           </a:xfrm>
           <a:prstGeom prst="rect">
@@ -23141,13 +23100,13 @@
       </p:sp>
       <p:sp>
         <p:nvSpPr>
-          <p:cNvPr id="33" name="TextBox 32"/>
+          <p:cNvPr id="32" name="TextBox 31"/>
           <p:cNvSpPr txBox="1"/>
           <p:nvPr/>
         </p:nvSpPr>
         <p:spPr>
           <a:xfrm>
-            <a:off x="4353458" y="3712463"/>
+            <a:off x="4353458" y="3602736"/>
             <a:ext cx="3484778" cy="256032"/>
           </a:xfrm>
           <a:prstGeom prst="rect">
@@ -23182,13 +23141,13 @@
       </p:sp>
       <p:sp>
         <p:nvSpPr>
-          <p:cNvPr id="34" name="TextBox 33"/>
+          <p:cNvPr id="33" name="TextBox 32"/>
           <p:cNvSpPr txBox="1"/>
           <p:nvPr/>
         </p:nvSpPr>
         <p:spPr>
           <a:xfrm>
-            <a:off x="4536338" y="3950208"/>
+            <a:off x="4536338" y="3822191"/>
             <a:ext cx="3301898" cy="256032"/>
           </a:xfrm>
           <a:prstGeom prst="rect">
@@ -23223,13 +23182,13 @@
       </p:sp>
       <p:sp>
         <p:nvSpPr>
-          <p:cNvPr id="35" name="TextBox 34"/>
+          <p:cNvPr id="34" name="TextBox 33"/>
           <p:cNvSpPr txBox="1"/>
           <p:nvPr/>
         </p:nvSpPr>
         <p:spPr>
           <a:xfrm>
-            <a:off x="8021116" y="3712463"/>
+            <a:off x="8021116" y="3602736"/>
             <a:ext cx="3484778" cy="256032"/>
           </a:xfrm>
           <a:prstGeom prst="rect">
@@ -23264,13 +23223,13 @@
       </p:sp>
       <p:sp>
         <p:nvSpPr>
-          <p:cNvPr id="36" name="TextBox 35"/>
+          <p:cNvPr id="35" name="TextBox 34"/>
           <p:cNvSpPr txBox="1"/>
           <p:nvPr/>
         </p:nvSpPr>
         <p:spPr>
           <a:xfrm>
-            <a:off x="8203996" y="3950208"/>
+            <a:off x="8203996" y="3822191"/>
             <a:ext cx="3301898" cy="256032"/>
           </a:xfrm>
           <a:prstGeom prst="rect">
@@ -23305,14 +23264,392 @@
       </p:sp>
       <p:sp>
         <p:nvSpPr>
-          <p:cNvPr id="37" name="Rectangle 36"/>
+          <p:cNvPr id="36" name="Rectangle 35"/>
           <p:cNvSpPr/>
           <p:nvPr/>
         </p:nvSpPr>
         <p:spPr>
           <a:xfrm>
-            <a:off x="502920" y="4389120"/>
-            <a:ext cx="11185855" cy="1481328"/>
+            <a:off x="685800" y="4133087"/>
+            <a:ext cx="3484778" cy="566928"/>
+          </a:xfrm>
+          <a:prstGeom prst="rect">
+            <a:avLst/>
+          </a:prstGeom>
+          <a:solidFill>
+            <a:srgbClr val="FFFFFF"/>
+          </a:solidFill>
+          <a:ln w="9525">
+            <a:solidFill>
+              <a:srgbClr val="9E9E9E"/>
+            </a:solidFill>
+          </a:ln>
+          <a:effectLst/>
+        </p:spPr>
+        <p:style>
+          <a:lnRef idx="1">
+            <a:schemeClr val="accent1"/>
+          </a:lnRef>
+          <a:fillRef idx="3">
+            <a:schemeClr val="accent1"/>
+          </a:fillRef>
+          <a:effectRef idx="2">
+            <a:schemeClr val="accent1"/>
+          </a:effectRef>
+          <a:fontRef idx="minor">
+            <a:schemeClr val="lt1"/>
+          </a:fontRef>
+        </p:style>
+        <p:txBody>
+          <a:bodyPr rtlCol="0" anchor="ctr"/>
+          <a:lstStyle/>
+          <a:p/>
+        </p:txBody>
+      </p:sp>
+      <p:sp>
+        <p:nvSpPr>
+          <p:cNvPr id="37" name="TextBox 36"/>
+          <p:cNvSpPr txBox="1"/>
+          <p:nvPr/>
+        </p:nvSpPr>
+        <p:spPr>
+          <a:xfrm>
+            <a:off x="685800" y="4151376"/>
+            <a:ext cx="3484778" cy="310896"/>
+          </a:xfrm>
+          <a:prstGeom prst="rect">
+            <a:avLst/>
+          </a:prstGeom>
+          <a:noFill/>
+        </p:spPr>
+        <p:txBody>
+          <a:bodyPr wrap="square" lIns="18288" rIns="18288" tIns="10972" bIns="10972" anchor="t">
+            <a:spAutoFit/>
+          </a:bodyPr>
+          <a:lstStyle/>
+          <a:p>
+            <a:pPr algn="ctr">
+              <a:spcAft>
+                <a:spcPts val="500"/>
+              </a:spcAft>
+            </a:pPr>
+            <a:r>
+              <a:rPr sz="1700" b="1" i="0">
+                <a:solidFill>
+                  <a:srgbClr val="111111"/>
+                </a:solidFill>
+                <a:latin typeface="Meiryo"/>
+                <a:ea typeface="Meiryo"/>
+                <a:cs typeface="Meiryo"/>
+              </a:rPr>
+              <a:t>14 時間</a:t>
+            </a:r>
+          </a:p>
+        </p:txBody>
+      </p:sp>
+      <p:sp>
+        <p:nvSpPr>
+          <p:cNvPr id="38" name="TextBox 37"/>
+          <p:cNvSpPr txBox="1"/>
+          <p:nvPr/>
+        </p:nvSpPr>
+        <p:spPr>
+          <a:xfrm>
+            <a:off x="685800" y="4443984"/>
+            <a:ext cx="3484778" cy="237744"/>
+          </a:xfrm>
+          <a:prstGeom prst="rect">
+            <a:avLst/>
+          </a:prstGeom>
+          <a:noFill/>
+        </p:spPr>
+        <p:txBody>
+          <a:bodyPr wrap="square" lIns="18288" rIns="18288" tIns="10972" bIns="10972" anchor="t">
+            <a:spAutoFit/>
+          </a:bodyPr>
+          <a:lstStyle/>
+          <a:p>
+            <a:pPr algn="ctr">
+              <a:spcAft>
+                <a:spcPts val="500"/>
+              </a:spcAft>
+            </a:pPr>
+            <a:r>
+              <a:rPr sz="1050" b="0" i="0">
+                <a:solidFill>
+                  <a:srgbClr val="4A4A4A"/>
+                </a:solidFill>
+                <a:latin typeface="Meiryo"/>
+                <a:ea typeface="Meiryo"/>
+                <a:cs typeface="Meiryo"/>
+              </a:rPr>
+              <a:t>実作業時間 (ログのイベント間隔から集計)</a:t>
+            </a:r>
+          </a:p>
+        </p:txBody>
+      </p:sp>
+      <p:sp>
+        <p:nvSpPr>
+          <p:cNvPr id="39" name="Rectangle 38"/>
+          <p:cNvSpPr/>
+          <p:nvPr/>
+        </p:nvSpPr>
+        <p:spPr>
+          <a:xfrm>
+            <a:off x="4353458" y="4133087"/>
+            <a:ext cx="3484778" cy="566928"/>
+          </a:xfrm>
+          <a:prstGeom prst="rect">
+            <a:avLst/>
+          </a:prstGeom>
+          <a:solidFill>
+            <a:srgbClr val="FFFFFF"/>
+          </a:solidFill>
+          <a:ln w="9525">
+            <a:solidFill>
+              <a:srgbClr val="9E9E9E"/>
+            </a:solidFill>
+          </a:ln>
+          <a:effectLst/>
+        </p:spPr>
+        <p:style>
+          <a:lnRef idx="1">
+            <a:schemeClr val="accent1"/>
+          </a:lnRef>
+          <a:fillRef idx="3">
+            <a:schemeClr val="accent1"/>
+          </a:fillRef>
+          <a:effectRef idx="2">
+            <a:schemeClr val="accent1"/>
+          </a:effectRef>
+          <a:fontRef idx="minor">
+            <a:schemeClr val="lt1"/>
+          </a:fontRef>
+        </p:style>
+        <p:txBody>
+          <a:bodyPr rtlCol="0" anchor="ctr"/>
+          <a:lstStyle/>
+          <a:p/>
+        </p:txBody>
+      </p:sp>
+      <p:sp>
+        <p:nvSpPr>
+          <p:cNvPr id="40" name="TextBox 39"/>
+          <p:cNvSpPr txBox="1"/>
+          <p:nvPr/>
+        </p:nvSpPr>
+        <p:spPr>
+          <a:xfrm>
+            <a:off x="4353458" y="4151376"/>
+            <a:ext cx="3484778" cy="310896"/>
+          </a:xfrm>
+          <a:prstGeom prst="rect">
+            <a:avLst/>
+          </a:prstGeom>
+          <a:noFill/>
+        </p:spPr>
+        <p:txBody>
+          <a:bodyPr wrap="square" lIns="18288" rIns="18288" tIns="10972" bIns="10972" anchor="t">
+            <a:spAutoFit/>
+          </a:bodyPr>
+          <a:lstStyle/>
+          <a:p>
+            <a:pPr algn="ctr">
+              <a:spcAft>
+                <a:spcPts val="500"/>
+              </a:spcAft>
+            </a:pPr>
+            <a:r>
+              <a:rPr sz="1700" b="1" i="0">
+                <a:solidFill>
+                  <a:srgbClr val="111111"/>
+                </a:solidFill>
+                <a:latin typeface="Meiryo"/>
+                <a:ea typeface="Meiryo"/>
+                <a:cs typeface="Meiryo"/>
+              </a:rPr>
+              <a:t>$480</a:t>
+            </a:r>
+          </a:p>
+        </p:txBody>
+      </p:sp>
+      <p:sp>
+        <p:nvSpPr>
+          <p:cNvPr id="41" name="TextBox 40"/>
+          <p:cNvSpPr txBox="1"/>
+          <p:nvPr/>
+        </p:nvSpPr>
+        <p:spPr>
+          <a:xfrm>
+            <a:off x="4353458" y="4443984"/>
+            <a:ext cx="3484778" cy="237744"/>
+          </a:xfrm>
+          <a:prstGeom prst="rect">
+            <a:avLst/>
+          </a:prstGeom>
+          <a:noFill/>
+        </p:spPr>
+        <p:txBody>
+          <a:bodyPr wrap="square" lIns="18288" rIns="18288" tIns="10972" bIns="10972" anchor="t">
+            <a:spAutoFit/>
+          </a:bodyPr>
+          <a:lstStyle/>
+          <a:p>
+            <a:pPr algn="ctr">
+              <a:spcAft>
+                <a:spcPts val="500"/>
+              </a:spcAft>
+            </a:pPr>
+            <a:r>
+              <a:rPr sz="1050" b="0" i="0">
+                <a:solidFill>
+                  <a:srgbClr val="4A4A4A"/>
+                </a:solidFill>
+                <a:latin typeface="Meiryo"/>
+                <a:ea typeface="Meiryo"/>
+                <a:cs typeface="Meiryo"/>
+              </a:rPr>
+              <a:t>API 料金換算。83% がプロンプトキャッシュ</a:t>
+            </a:r>
+          </a:p>
+        </p:txBody>
+      </p:sp>
+      <p:sp>
+        <p:nvSpPr>
+          <p:cNvPr id="42" name="Rectangle 41"/>
+          <p:cNvSpPr/>
+          <p:nvPr/>
+        </p:nvSpPr>
+        <p:spPr>
+          <a:xfrm>
+            <a:off x="8021116" y="4133087"/>
+            <a:ext cx="3484778" cy="566928"/>
+          </a:xfrm>
+          <a:prstGeom prst="rect">
+            <a:avLst/>
+          </a:prstGeom>
+          <a:solidFill>
+            <a:srgbClr val="FFFFFF"/>
+          </a:solidFill>
+          <a:ln w="9525">
+            <a:solidFill>
+              <a:srgbClr val="9E9E9E"/>
+            </a:solidFill>
+          </a:ln>
+          <a:effectLst/>
+        </p:spPr>
+        <p:style>
+          <a:lnRef idx="1">
+            <a:schemeClr val="accent1"/>
+          </a:lnRef>
+          <a:fillRef idx="3">
+            <a:schemeClr val="accent1"/>
+          </a:fillRef>
+          <a:effectRef idx="2">
+            <a:schemeClr val="accent1"/>
+          </a:effectRef>
+          <a:fontRef idx="minor">
+            <a:schemeClr val="lt1"/>
+          </a:fontRef>
+        </p:style>
+        <p:txBody>
+          <a:bodyPr rtlCol="0" anchor="ctr"/>
+          <a:lstStyle/>
+          <a:p/>
+        </p:txBody>
+      </p:sp>
+      <p:sp>
+        <p:nvSpPr>
+          <p:cNvPr id="43" name="TextBox 42"/>
+          <p:cNvSpPr txBox="1"/>
+          <p:nvPr/>
+        </p:nvSpPr>
+        <p:spPr>
+          <a:xfrm>
+            <a:off x="8021116" y="4151376"/>
+            <a:ext cx="3484778" cy="310896"/>
+          </a:xfrm>
+          <a:prstGeom prst="rect">
+            <a:avLst/>
+          </a:prstGeom>
+          <a:noFill/>
+        </p:spPr>
+        <p:txBody>
+          <a:bodyPr wrap="square" lIns="18288" rIns="18288" tIns="10972" bIns="10972" anchor="t">
+            <a:spAutoFit/>
+          </a:bodyPr>
+          <a:lstStyle/>
+          <a:p>
+            <a:pPr algn="ctr">
+              <a:spcAft>
+                <a:spcPts val="500"/>
+              </a:spcAft>
+            </a:pPr>
+            <a:r>
+              <a:rPr sz="1700" b="1" i="0">
+                <a:solidFill>
+                  <a:srgbClr val="111111"/>
+                </a:solidFill>
+                <a:latin typeface="Meiryo"/>
+                <a:ea typeface="Meiryo"/>
+                <a:cs typeface="Meiryo"/>
+              </a:rPr>
+              <a:t>103 コミット</a:t>
+            </a:r>
+          </a:p>
+        </p:txBody>
+      </p:sp>
+      <p:sp>
+        <p:nvSpPr>
+          <p:cNvPr id="44" name="TextBox 43"/>
+          <p:cNvSpPr txBox="1"/>
+          <p:nvPr/>
+        </p:nvSpPr>
+        <p:spPr>
+          <a:xfrm>
+            <a:off x="8021116" y="4443984"/>
+            <a:ext cx="3484778" cy="237744"/>
+          </a:xfrm>
+          <a:prstGeom prst="rect">
+            <a:avLst/>
+          </a:prstGeom>
+          <a:noFill/>
+        </p:spPr>
+        <p:txBody>
+          <a:bodyPr wrap="square" lIns="18288" rIns="18288" tIns="10972" bIns="10972" anchor="t">
+            <a:spAutoFit/>
+          </a:bodyPr>
+          <a:lstStyle/>
+          <a:p>
+            <a:pPr algn="ctr">
+              <a:spcAft>
+                <a:spcPts val="500"/>
+              </a:spcAft>
+            </a:pPr>
+            <a:r>
+              <a:rPr sz="1050" b="0" i="0">
+                <a:solidFill>
+                  <a:srgbClr val="4A4A4A"/>
+                </a:solidFill>
+                <a:latin typeface="Meiryo"/>
+                <a:ea typeface="Meiryo"/>
+                <a:cs typeface="Meiryo"/>
+              </a:rPr>
+              <a:t>うち 102 が Co-Authored-By: Claude</a:t>
+            </a:r>
+          </a:p>
+        </p:txBody>
+      </p:sp>
+      <p:sp>
+        <p:nvSpPr>
+          <p:cNvPr id="45" name="Rectangle 44"/>
+          <p:cNvSpPr/>
+          <p:nvPr/>
+        </p:nvSpPr>
+        <p:spPr>
+          <a:xfrm>
+            <a:off x="502920" y="4937760"/>
+            <a:ext cx="11185855" cy="1060704"/>
           </a:xfrm>
           <a:prstGeom prst="rect">
             <a:avLst/>
@@ -23349,14 +23686,14 @@
       </p:sp>
       <p:sp>
         <p:nvSpPr>
-          <p:cNvPr id="38" name="Rectangle 37"/>
+          <p:cNvPr id="46" name="Rectangle 45"/>
           <p:cNvSpPr/>
           <p:nvPr/>
         </p:nvSpPr>
         <p:spPr>
           <a:xfrm>
-            <a:off x="502920" y="4389120"/>
-            <a:ext cx="11185855" cy="438912"/>
+            <a:off x="502920" y="4937760"/>
+            <a:ext cx="11185855" cy="384048"/>
           </a:xfrm>
           <a:prstGeom prst="rect">
             <a:avLst/>
@@ -23393,14 +23730,14 @@
       </p:sp>
       <p:sp>
         <p:nvSpPr>
-          <p:cNvPr id="39" name="TextBox 38"/>
+          <p:cNvPr id="47" name="TextBox 46"/>
           <p:cNvSpPr txBox="1"/>
           <p:nvPr/>
         </p:nvSpPr>
         <p:spPr>
           <a:xfrm>
-            <a:off x="502920" y="4389120"/>
-            <a:ext cx="11185855" cy="438912"/>
+            <a:off x="502920" y="4937760"/>
+            <a:ext cx="11185855" cy="384048"/>
           </a:xfrm>
           <a:prstGeom prst="rect">
             <a:avLst/>
@@ -23419,7 +23756,7 @@
               </a:spcAft>
             </a:pPr>
             <a:r>
-              <a:rPr sz="1500" b="1" i="0">
+              <a:rPr sz="1450" b="1" i="0">
                 <a:solidFill>
                   <a:srgbClr val="111111"/>
                 </a:solidFill>
@@ -23434,14 +23771,14 @@
       </p:sp>
       <p:sp>
         <p:nvSpPr>
-          <p:cNvPr id="40" name="Rectangle 39"/>
+          <p:cNvPr id="48" name="Rectangle 47"/>
           <p:cNvSpPr/>
           <p:nvPr/>
         </p:nvSpPr>
         <p:spPr>
           <a:xfrm>
-            <a:off x="777240" y="4919472"/>
-            <a:ext cx="1559509" cy="548640"/>
+            <a:off x="777240" y="5394960"/>
+            <a:ext cx="1559509" cy="493776"/>
           </a:xfrm>
           <a:prstGeom prst="rect">
             <a:avLst/>
@@ -23478,14 +23815,14 @@
       </p:sp>
       <p:sp>
         <p:nvSpPr>
-          <p:cNvPr id="41" name="TextBox 40"/>
+          <p:cNvPr id="49" name="TextBox 48"/>
           <p:cNvSpPr txBox="1"/>
           <p:nvPr/>
         </p:nvSpPr>
         <p:spPr>
           <a:xfrm>
-            <a:off x="777240" y="4919472"/>
-            <a:ext cx="1559509" cy="548640"/>
+            <a:off x="777240" y="5394960"/>
+            <a:ext cx="1559509" cy="493776"/>
           </a:xfrm>
           <a:prstGeom prst="rect">
             <a:avLst/>
@@ -23504,7 +23841,7 @@
               </a:spcAft>
             </a:pPr>
             <a:r>
-              <a:rPr sz="1350" b="1" i="0">
+              <a:rPr sz="1300" b="1" i="0">
                 <a:solidFill>
                   <a:srgbClr val="111111"/>
                 </a:solidFill>
@@ -23519,13 +23856,13 @@
       </p:sp>
       <p:sp>
         <p:nvSpPr>
-          <p:cNvPr id="42" name="Right Arrow 41"/>
+          <p:cNvPr id="50" name="Right Arrow 49"/>
           <p:cNvSpPr/>
           <p:nvPr/>
         </p:nvSpPr>
         <p:spPr>
           <a:xfrm>
-            <a:off x="2345893" y="5056632"/>
+            <a:off x="2345893" y="5504688"/>
             <a:ext cx="237744" cy="274320"/>
           </a:xfrm>
           <a:prstGeom prst="rightArrow">
@@ -23563,14 +23900,14 @@
       </p:sp>
       <p:sp>
         <p:nvSpPr>
-          <p:cNvPr id="43" name="Rectangle 42"/>
+          <p:cNvPr id="51" name="Rectangle 50"/>
           <p:cNvSpPr/>
           <p:nvPr/>
         </p:nvSpPr>
         <p:spPr>
           <a:xfrm>
-            <a:off x="2592781" y="4919472"/>
-            <a:ext cx="1559509" cy="548640"/>
+            <a:off x="2592781" y="5394960"/>
+            <a:ext cx="1559509" cy="493776"/>
           </a:xfrm>
           <a:prstGeom prst="rect">
             <a:avLst/>
@@ -23607,14 +23944,14 @@
       </p:sp>
       <p:sp>
         <p:nvSpPr>
-          <p:cNvPr id="44" name="TextBox 43"/>
+          <p:cNvPr id="52" name="TextBox 51"/>
           <p:cNvSpPr txBox="1"/>
           <p:nvPr/>
         </p:nvSpPr>
         <p:spPr>
           <a:xfrm>
-            <a:off x="2592781" y="4919472"/>
-            <a:ext cx="1559509" cy="548640"/>
+            <a:off x="2592781" y="5394960"/>
+            <a:ext cx="1559509" cy="493776"/>
           </a:xfrm>
           <a:prstGeom prst="rect">
             <a:avLst/>
@@ -23633,7 +23970,7 @@
               </a:spcAft>
             </a:pPr>
             <a:r>
-              <a:rPr sz="1350" b="1" i="0">
+              <a:rPr sz="1300" b="1" i="0">
                 <a:solidFill>
                   <a:srgbClr val="111111"/>
                 </a:solidFill>
@@ -23648,13 +23985,13 @@
       </p:sp>
       <p:sp>
         <p:nvSpPr>
-          <p:cNvPr id="45" name="Right Arrow 44"/>
+          <p:cNvPr id="53" name="Right Arrow 52"/>
           <p:cNvSpPr/>
           <p:nvPr/>
         </p:nvSpPr>
         <p:spPr>
           <a:xfrm>
-            <a:off x="4161434" y="5056632"/>
+            <a:off x="4161434" y="5504688"/>
             <a:ext cx="237744" cy="274320"/>
           </a:xfrm>
           <a:prstGeom prst="rightArrow">
@@ -23692,14 +24029,14 @@
       </p:sp>
       <p:sp>
         <p:nvSpPr>
-          <p:cNvPr id="46" name="Rectangle 45"/>
+          <p:cNvPr id="54" name="Rectangle 53"/>
           <p:cNvSpPr/>
           <p:nvPr/>
         </p:nvSpPr>
         <p:spPr>
           <a:xfrm>
-            <a:off x="4408322" y="4919472"/>
-            <a:ext cx="1559509" cy="548640"/>
+            <a:off x="4408322" y="5394960"/>
+            <a:ext cx="1559509" cy="493776"/>
           </a:xfrm>
           <a:prstGeom prst="rect">
             <a:avLst/>
@@ -23736,14 +24073,14 @@
       </p:sp>
       <p:sp>
         <p:nvSpPr>
-          <p:cNvPr id="47" name="TextBox 46"/>
+          <p:cNvPr id="55" name="TextBox 54"/>
           <p:cNvSpPr txBox="1"/>
           <p:nvPr/>
         </p:nvSpPr>
         <p:spPr>
           <a:xfrm>
-            <a:off x="4408322" y="4919472"/>
-            <a:ext cx="1559509" cy="548640"/>
+            <a:off x="4408322" y="5394960"/>
+            <a:ext cx="1559509" cy="493776"/>
           </a:xfrm>
           <a:prstGeom prst="rect">
             <a:avLst/>
@@ -23762,7 +24099,7 @@
               </a:spcAft>
             </a:pPr>
             <a:r>
-              <a:rPr sz="1350" b="1" i="0">
+              <a:rPr sz="1300" b="1" i="0">
                 <a:solidFill>
                   <a:srgbClr val="111111"/>
                 </a:solidFill>
@@ -23777,13 +24114,13 @@
       </p:sp>
       <p:sp>
         <p:nvSpPr>
-          <p:cNvPr id="48" name="Right Arrow 47"/>
+          <p:cNvPr id="56" name="Right Arrow 55"/>
           <p:cNvSpPr/>
           <p:nvPr/>
         </p:nvSpPr>
         <p:spPr>
           <a:xfrm>
-            <a:off x="5976975" y="5056632"/>
+            <a:off x="5976975" y="5504688"/>
             <a:ext cx="237744" cy="274320"/>
           </a:xfrm>
           <a:prstGeom prst="rightArrow">
@@ -23821,14 +24158,14 @@
       </p:sp>
       <p:sp>
         <p:nvSpPr>
-          <p:cNvPr id="49" name="Rectangle 48"/>
+          <p:cNvPr id="57" name="Rectangle 56"/>
           <p:cNvSpPr/>
           <p:nvPr/>
         </p:nvSpPr>
         <p:spPr>
           <a:xfrm>
-            <a:off x="6223863" y="4919472"/>
-            <a:ext cx="1559509" cy="548640"/>
+            <a:off x="6223863" y="5394960"/>
+            <a:ext cx="1559509" cy="493776"/>
           </a:xfrm>
           <a:prstGeom prst="rect">
             <a:avLst/>
@@ -23865,14 +24202,14 @@
       </p:sp>
       <p:sp>
         <p:nvSpPr>
-          <p:cNvPr id="50" name="TextBox 49"/>
+          <p:cNvPr id="58" name="TextBox 57"/>
           <p:cNvSpPr txBox="1"/>
           <p:nvPr/>
         </p:nvSpPr>
         <p:spPr>
           <a:xfrm>
-            <a:off x="6223863" y="4919472"/>
-            <a:ext cx="1559509" cy="548640"/>
+            <a:off x="6223863" y="5394960"/>
+            <a:ext cx="1559509" cy="493776"/>
           </a:xfrm>
           <a:prstGeom prst="rect">
             <a:avLst/>
@@ -23891,7 +24228,7 @@
               </a:spcAft>
             </a:pPr>
             <a:r>
-              <a:rPr sz="1350" b="1" i="0">
+              <a:rPr sz="1300" b="1" i="0">
                 <a:solidFill>
                   <a:srgbClr val="111111"/>
                 </a:solidFill>
@@ -23906,13 +24243,13 @@
       </p:sp>
       <p:sp>
         <p:nvSpPr>
-          <p:cNvPr id="51" name="Right Arrow 50"/>
+          <p:cNvPr id="59" name="Right Arrow 58"/>
           <p:cNvSpPr/>
           <p:nvPr/>
         </p:nvSpPr>
         <p:spPr>
           <a:xfrm>
-            <a:off x="7792516" y="5056632"/>
+            <a:off x="7792516" y="5504688"/>
             <a:ext cx="237744" cy="274320"/>
           </a:xfrm>
           <a:prstGeom prst="rightArrow">
@@ -23950,14 +24287,14 @@
       </p:sp>
       <p:sp>
         <p:nvSpPr>
-          <p:cNvPr id="52" name="Rectangle 51"/>
+          <p:cNvPr id="60" name="Rectangle 59"/>
           <p:cNvSpPr/>
           <p:nvPr/>
         </p:nvSpPr>
         <p:spPr>
           <a:xfrm>
-            <a:off x="8039404" y="4919472"/>
-            <a:ext cx="1559509" cy="548640"/>
+            <a:off x="8039404" y="5394960"/>
+            <a:ext cx="1559509" cy="493776"/>
           </a:xfrm>
           <a:prstGeom prst="rect">
             <a:avLst/>
@@ -23994,14 +24331,14 @@
       </p:sp>
       <p:sp>
         <p:nvSpPr>
-          <p:cNvPr id="53" name="TextBox 52"/>
+          <p:cNvPr id="61" name="TextBox 60"/>
           <p:cNvSpPr txBox="1"/>
           <p:nvPr/>
         </p:nvSpPr>
         <p:spPr>
           <a:xfrm>
-            <a:off x="8039404" y="4919472"/>
-            <a:ext cx="1559509" cy="548640"/>
+            <a:off x="8039404" y="5394960"/>
+            <a:ext cx="1559509" cy="493776"/>
           </a:xfrm>
           <a:prstGeom prst="rect">
             <a:avLst/>
@@ -24020,7 +24357,7 @@
               </a:spcAft>
             </a:pPr>
             <a:r>
-              <a:rPr sz="1350" b="1" i="0">
+              <a:rPr sz="1300" b="1" i="0">
                 <a:solidFill>
                   <a:srgbClr val="111111"/>
                 </a:solidFill>
@@ -24035,13 +24372,13 @@
       </p:sp>
       <p:sp>
         <p:nvSpPr>
-          <p:cNvPr id="54" name="Right Arrow 53"/>
+          <p:cNvPr id="62" name="Right Arrow 61"/>
           <p:cNvSpPr/>
           <p:nvPr/>
         </p:nvSpPr>
         <p:spPr>
           <a:xfrm>
-            <a:off x="9608058" y="5056632"/>
+            <a:off x="9608058" y="5504688"/>
             <a:ext cx="237744" cy="274320"/>
           </a:xfrm>
           <a:prstGeom prst="rightArrow">
@@ -24079,14 +24416,14 @@
       </p:sp>
       <p:sp>
         <p:nvSpPr>
-          <p:cNvPr id="55" name="Rectangle 54"/>
+          <p:cNvPr id="63" name="Rectangle 62"/>
           <p:cNvSpPr/>
           <p:nvPr/>
         </p:nvSpPr>
         <p:spPr>
           <a:xfrm>
-            <a:off x="9854946" y="4919472"/>
-            <a:ext cx="1559509" cy="548640"/>
+            <a:off x="9854946" y="5394960"/>
+            <a:ext cx="1559509" cy="493776"/>
           </a:xfrm>
           <a:prstGeom prst="rect">
             <a:avLst/>
@@ -24123,14 +24460,14 @@
       </p:sp>
       <p:sp>
         <p:nvSpPr>
-          <p:cNvPr id="56" name="TextBox 55"/>
+          <p:cNvPr id="64" name="TextBox 63"/>
           <p:cNvSpPr txBox="1"/>
           <p:nvPr/>
         </p:nvSpPr>
         <p:spPr>
           <a:xfrm>
-            <a:off x="9854946" y="4919472"/>
-            <a:ext cx="1559509" cy="548640"/>
+            <a:off x="9854946" y="5394960"/>
+            <a:ext cx="1559509" cy="493776"/>
           </a:xfrm>
           <a:prstGeom prst="rect">
             <a:avLst/>
@@ -24149,7 +24486,7 @@
               </a:spcAft>
             </a:pPr>
             <a:r>
-              <a:rPr sz="1350" b="1" i="0">
+              <a:rPr sz="1300" b="1" i="0">
                 <a:solidFill>
                   <a:srgbClr val="111111"/>
                 </a:solidFill>
@@ -24164,55 +24501,14 @@
       </p:sp>
       <p:sp>
         <p:nvSpPr>
-          <p:cNvPr id="57" name="TextBox 56"/>
+          <p:cNvPr id="65" name="TextBox 64"/>
           <p:cNvSpPr txBox="1"/>
           <p:nvPr/>
         </p:nvSpPr>
         <p:spPr>
           <a:xfrm>
-            <a:off x="502920" y="5522976"/>
-            <a:ext cx="11185855" cy="310896"/>
-          </a:xfrm>
-          <a:prstGeom prst="rect">
-            <a:avLst/>
-          </a:prstGeom>
-          <a:noFill/>
-        </p:spPr>
-        <p:txBody>
-          <a:bodyPr wrap="square" lIns="0" rIns="0" tIns="0" bIns="0" anchor="t">
-            <a:spAutoFit/>
-          </a:bodyPr>
-          <a:lstStyle/>
-          <a:p>
-            <a:pPr algn="ctr">
-              <a:spcAft>
-                <a:spcPts val="500"/>
-              </a:spcAft>
-            </a:pPr>
-            <a:r>
-              <a:rPr sz="1300" b="0" i="0">
-                <a:solidFill>
-                  <a:srgbClr val="4A4A4A"/>
-                </a:solidFill>
-                <a:latin typeface="Meiryo"/>
-                <a:ea typeface="Meiryo"/>
-                <a:cs typeface="Meiryo"/>
-              </a:rPr>
-              <a:t>② が緑にならないうちは ④ に進まない — 焼いてから気づくと左右 2 個ぶんやり直し</a:t>
-            </a:r>
-          </a:p>
-        </p:txBody>
-      </p:sp>
-      <p:sp>
-        <p:nvSpPr>
-          <p:cNvPr id="58" name="TextBox 57"/>
-          <p:cNvSpPr txBox="1"/>
-          <p:nvPr/>
-        </p:nvSpPr>
-        <p:spPr>
-          <a:xfrm>
-            <a:off x="502920" y="5998464"/>
-            <a:ext cx="11185855" cy="365760"/>
+            <a:off x="502920" y="6089904"/>
+            <a:ext cx="11185855" cy="347472"/>
           </a:xfrm>
           <a:prstGeom prst="rect">
             <a:avLst/>

</xml_diff>